<commit_message>
Perfektionierung Netzplan & PSP: Hochaufloesende Vektor-Grafiken, DIN 69900 Berechnungstabellen, Einbettung in Praesentation & 3 Leitfaeden-PDFs
</commit_message>
<xml_diff>
--- a/docs/08_Projektabschluss/Abschlusspraesentation_VektorPlan.pptx
+++ b/docs/08_Projektabschluss/Abschlusspraesentation_VektorPlan.pptx
@@ -6,21 +6,21 @@
   </p:sldMasterIdLst>
   <p:sldIdLst>
     <p:sldId id="256" r:id="rId7"/>
-    <p:sldId id="257" r:id="rId8"/>
-    <p:sldId id="258" r:id="rId9"/>
-    <p:sldId id="259" r:id="rId10"/>
-    <p:sldId id="260" r:id="rId11"/>
-    <p:sldId id="261" r:id="rId12"/>
-    <p:sldId id="262" r:id="rId13"/>
-    <p:sldId id="263" r:id="rId14"/>
-    <p:sldId id="264" r:id="rId15"/>
-    <p:sldId id="265" r:id="rId16"/>
-    <p:sldId id="266" r:id="rId17"/>
-    <p:sldId id="267" r:id="rId18"/>
-    <p:sldId id="268" r:id="rId19"/>
-    <p:sldId id="269" r:id="rId20"/>
-    <p:sldId id="270" r:id="rId21"/>
-    <p:sldId id="271" r:id="rId22"/>
+    <p:sldId id="257" r:id="rId9"/>
+    <p:sldId id="258" r:id="rId10"/>
+    <p:sldId id="259" r:id="rId11"/>
+    <p:sldId id="260" r:id="rId12"/>
+    <p:sldId id="261" r:id="rId13"/>
+    <p:sldId id="262" r:id="rId14"/>
+    <p:sldId id="263" r:id="rId15"/>
+    <p:sldId id="264" r:id="rId16"/>
+    <p:sldId id="265" r:id="rId17"/>
+    <p:sldId id="266" r:id="rId18"/>
+    <p:sldId id="267" r:id="rId19"/>
+    <p:sldId id="268" r:id="rId20"/>
+    <p:sldId id="269" r:id="rId21"/>
+    <p:sldId id="270" r:id="rId22"/>
+    <p:sldId id="271" r:id="rId23"/>
   </p:sldIdLst>
   <p:sldSz cx="12191695" cy="6858000" type="screen4x3"/>
   <p:notesSz cx="6858000" cy="9144000"/>
@@ -120,6 +120,1721 @@
     </a:lvl9pPr>
   </p:defaultTextStyle>
 </p:presentation>
+</file>
+
+<file path=ppt/notesMasters/notesMaster1.xml><?xml version="1.0" encoding="utf-8"?>
+<p:notesMaster xmlns:a="http://schemas.openxmlformats.org/drawingml/2006/main" xmlns:p="http://schemas.openxmlformats.org/presentationml/2006/main" xmlns:r="http://schemas.openxmlformats.org/officeDocument/2006/relationships">
+  <p:cSld>
+    <p:bg>
+      <p:bgRef idx="1001">
+        <a:schemeClr val="bg1"/>
+      </p:bgRef>
+    </p:bg>
+    <p:spTree>
+      <p:nvGrpSpPr>
+        <p:cNvPr id="1" name=""/>
+        <p:cNvGrpSpPr/>
+        <p:nvPr/>
+      </p:nvGrpSpPr>
+      <p:grpSpPr>
+        <a:xfrm>
+          <a:off x="0" y="0"/>
+          <a:ext cx="0" cy="0"/>
+          <a:chOff x="0" y="0"/>
+          <a:chExt cx="0" cy="0"/>
+        </a:xfrm>
+      </p:grpSpPr>
+      <p:sp>
+        <p:nvSpPr>
+          <p:cNvPr id="2" name="Header Placeholder 1"/>
+          <p:cNvSpPr>
+            <a:spLocks noGrp="1"/>
+          </p:cNvSpPr>
+          <p:nvPr>
+            <p:ph type="hdr" sz="quarter"/>
+          </p:nvPr>
+        </p:nvSpPr>
+        <p:spPr>
+          <a:xfrm>
+            <a:off x="0" y="0"/>
+            <a:ext cx="2971800" cy="457200"/>
+          </a:xfrm>
+          <a:prstGeom prst="rect">
+            <a:avLst/>
+          </a:prstGeom>
+        </p:spPr>
+        <p:txBody>
+          <a:bodyPr vert="horz" lIns="91440" tIns="45720" rIns="91440" bIns="45720" rtlCol="0"/>
+          <a:lstStyle>
+            <a:lvl1pPr algn="l">
+              <a:defRPr sz="1200"/>
+            </a:lvl1pPr>
+          </a:lstStyle>
+          <a:p>
+            <a:endParaRPr lang="en-US"/>
+          </a:p>
+        </p:txBody>
+      </p:sp>
+      <p:sp>
+        <p:nvSpPr>
+          <p:cNvPr id="3" name="Date Placeholder 2"/>
+          <p:cNvSpPr>
+            <a:spLocks noGrp="1"/>
+          </p:cNvSpPr>
+          <p:nvPr>
+            <p:ph type="dt" idx="1"/>
+          </p:nvPr>
+        </p:nvSpPr>
+        <p:spPr>
+          <a:xfrm>
+            <a:off x="3884613" y="0"/>
+            <a:ext cx="2971800" cy="457200"/>
+          </a:xfrm>
+          <a:prstGeom prst="rect">
+            <a:avLst/>
+          </a:prstGeom>
+        </p:spPr>
+        <p:txBody>
+          <a:bodyPr vert="horz" lIns="91440" tIns="45720" rIns="91440" bIns="45720" rtlCol="0"/>
+          <a:lstStyle>
+            <a:lvl1pPr algn="r">
+              <a:defRPr sz="1200"/>
+            </a:lvl1pPr>
+          </a:lstStyle>
+          <a:p>
+            <a:fld id="{0F89C1C7-3DCD-1040-A9CF-14679D8B5DDD}" type="datetimeFigureOut">
+              <a:rPr lang="en-US" smtClean="0"/>
+              <a:t>10/17/16</a:t>
+            </a:fld>
+            <a:endParaRPr lang="en-US"/>
+          </a:p>
+        </p:txBody>
+      </p:sp>
+      <p:sp>
+        <p:nvSpPr>
+          <p:cNvPr id="4" name="Slide Image Placeholder 3"/>
+          <p:cNvSpPr>
+            <a:spLocks noGrp="1" noRot="1" noChangeAspect="1"/>
+          </p:cNvSpPr>
+          <p:nvPr>
+            <p:ph type="sldImg" idx="2"/>
+          </p:nvPr>
+        </p:nvSpPr>
+        <p:spPr>
+          <a:xfrm>
+            <a:off x="1143000" y="685800"/>
+            <a:ext cx="4572000" cy="3429000"/>
+          </a:xfrm>
+          <a:prstGeom prst="rect">
+            <a:avLst/>
+          </a:prstGeom>
+          <a:noFill/>
+          <a:ln w="12700">
+            <a:solidFill>
+              <a:prstClr val="black"/>
+            </a:solidFill>
+          </a:ln>
+        </p:spPr>
+        <p:txBody>
+          <a:bodyPr vert="horz" lIns="91440" tIns="45720" rIns="91440" bIns="45720" rtlCol="0" anchor="ctr"/>
+          <a:lstStyle/>
+          <a:p>
+            <a:endParaRPr lang="en-US"/>
+          </a:p>
+        </p:txBody>
+      </p:sp>
+      <p:sp>
+        <p:nvSpPr>
+          <p:cNvPr id="5" name="Notes Placeholder 4"/>
+          <p:cNvSpPr>
+            <a:spLocks noGrp="1"/>
+          </p:cNvSpPr>
+          <p:nvPr>
+            <p:ph type="body" sz="quarter" idx="3"/>
+          </p:nvPr>
+        </p:nvSpPr>
+        <p:spPr>
+          <a:xfrm>
+            <a:off x="685800" y="4343400"/>
+            <a:ext cx="5486400" cy="4114800"/>
+          </a:xfrm>
+          <a:prstGeom prst="rect">
+            <a:avLst/>
+          </a:prstGeom>
+        </p:spPr>
+        <p:txBody>
+          <a:bodyPr vert="horz" lIns="91440" tIns="45720" rIns="91440" bIns="45720" rtlCol="0"/>
+          <a:lstStyle/>
+          <a:p>
+            <a:pPr lvl="0"/>
+            <a:r>
+              <a:rPr lang="en-US" smtClean="0"/>
+              <a:t>Click to edit Master text styles</a:t>
+            </a:r>
+          </a:p>
+          <a:p>
+            <a:pPr lvl="1"/>
+            <a:r>
+              <a:rPr lang="en-US" smtClean="0"/>
+              <a:t>Second level</a:t>
+            </a:r>
+          </a:p>
+          <a:p>
+            <a:pPr lvl="2"/>
+            <a:r>
+              <a:rPr lang="en-US" smtClean="0"/>
+              <a:t>Third level</a:t>
+            </a:r>
+          </a:p>
+          <a:p>
+            <a:pPr lvl="3"/>
+            <a:r>
+              <a:rPr lang="en-US" smtClean="0"/>
+              <a:t>Fourth level</a:t>
+            </a:r>
+          </a:p>
+          <a:p>
+            <a:pPr lvl="4"/>
+            <a:r>
+              <a:rPr lang="en-US" smtClean="0"/>
+              <a:t>Fifth level</a:t>
+            </a:r>
+            <a:endParaRPr lang="en-US"/>
+          </a:p>
+        </p:txBody>
+      </p:sp>
+      <p:sp>
+        <p:nvSpPr>
+          <p:cNvPr id="6" name="Footer Placeholder 5"/>
+          <p:cNvSpPr>
+            <a:spLocks noGrp="1"/>
+          </p:cNvSpPr>
+          <p:nvPr>
+            <p:ph type="ftr" sz="quarter" idx="4"/>
+          </p:nvPr>
+        </p:nvSpPr>
+        <p:spPr>
+          <a:xfrm>
+            <a:off x="0" y="8685213"/>
+            <a:ext cx="2971800" cy="457200"/>
+          </a:xfrm>
+          <a:prstGeom prst="rect">
+            <a:avLst/>
+          </a:prstGeom>
+        </p:spPr>
+        <p:txBody>
+          <a:bodyPr vert="horz" lIns="91440" tIns="45720" rIns="91440" bIns="45720" rtlCol="0" anchor="b"/>
+          <a:lstStyle>
+            <a:lvl1pPr algn="l">
+              <a:defRPr sz="1200"/>
+            </a:lvl1pPr>
+          </a:lstStyle>
+          <a:p>
+            <a:endParaRPr lang="en-US"/>
+          </a:p>
+        </p:txBody>
+      </p:sp>
+      <p:sp>
+        <p:nvSpPr>
+          <p:cNvPr id="7" name="Slide Number Placeholder 6"/>
+          <p:cNvSpPr>
+            <a:spLocks noGrp="1"/>
+          </p:cNvSpPr>
+          <p:nvPr>
+            <p:ph type="sldNum" sz="quarter" idx="5"/>
+          </p:nvPr>
+        </p:nvSpPr>
+        <p:spPr>
+          <a:xfrm>
+            <a:off x="3884613" y="8685213"/>
+            <a:ext cx="2971800" cy="457200"/>
+          </a:xfrm>
+          <a:prstGeom prst="rect">
+            <a:avLst/>
+          </a:prstGeom>
+        </p:spPr>
+        <p:txBody>
+          <a:bodyPr vert="horz" lIns="91440" tIns="45720" rIns="91440" bIns="45720" rtlCol="0" anchor="b"/>
+          <a:lstStyle>
+            <a:lvl1pPr algn="r">
+              <a:defRPr sz="1200"/>
+            </a:lvl1pPr>
+          </a:lstStyle>
+          <a:p>
+            <a:fld id="{BB5E49A5-4136-284D-997B-48E1D791AD67}" type="slidenum">
+              <a:rPr lang="en-US" smtClean="0"/>
+              <a:t>‹#›</a:t>
+            </a:fld>
+            <a:endParaRPr lang="en-US"/>
+          </a:p>
+        </p:txBody>
+      </p:sp>
+    </p:spTree>
+    <p:extLst>
+      <p:ext uri="{BB962C8B-B14F-4D97-AF65-F5344CB8AC3E}">
+        <p14:creationId xmlns:p14="http://schemas.microsoft.com/office/powerpoint/2010/main" val="2623252185"/>
+      </p:ext>
+    </p:extLst>
+  </p:cSld>
+  <p:clrMap bg1="lt1" tx1="dk1" bg2="lt2" tx2="dk2" accent1="accent1" accent2="accent2" accent3="accent3" accent4="accent4" accent5="accent5" accent6="accent6" hlink="hlink" folHlink="folHlink"/>
+  <p:notesStyle>
+    <a:lvl1pPr marL="0" algn="l" defTabSz="457200" rtl="0" eaLnBrk="1" latinLnBrk="0" hangingPunct="1">
+      <a:defRPr sz="1200" kern="1200">
+        <a:solidFill>
+          <a:schemeClr val="tx1"/>
+        </a:solidFill>
+        <a:latin typeface="+mn-lt"/>
+        <a:ea typeface="+mn-ea"/>
+        <a:cs typeface="+mn-cs"/>
+      </a:defRPr>
+    </a:lvl1pPr>
+    <a:lvl2pPr marL="457200" algn="l" defTabSz="457200" rtl="0" eaLnBrk="1" latinLnBrk="0" hangingPunct="1">
+      <a:defRPr sz="1200" kern="1200">
+        <a:solidFill>
+          <a:schemeClr val="tx1"/>
+        </a:solidFill>
+        <a:latin typeface="+mn-lt"/>
+        <a:ea typeface="+mn-ea"/>
+        <a:cs typeface="+mn-cs"/>
+      </a:defRPr>
+    </a:lvl2pPr>
+    <a:lvl3pPr marL="914400" algn="l" defTabSz="457200" rtl="0" eaLnBrk="1" latinLnBrk="0" hangingPunct="1">
+      <a:defRPr sz="1200" kern="1200">
+        <a:solidFill>
+          <a:schemeClr val="tx1"/>
+        </a:solidFill>
+        <a:latin typeface="+mn-lt"/>
+        <a:ea typeface="+mn-ea"/>
+        <a:cs typeface="+mn-cs"/>
+      </a:defRPr>
+    </a:lvl3pPr>
+    <a:lvl4pPr marL="1371600" algn="l" defTabSz="457200" rtl="0" eaLnBrk="1" latinLnBrk="0" hangingPunct="1">
+      <a:defRPr sz="1200" kern="1200">
+        <a:solidFill>
+          <a:schemeClr val="tx1"/>
+        </a:solidFill>
+        <a:latin typeface="+mn-lt"/>
+        <a:ea typeface="+mn-ea"/>
+        <a:cs typeface="+mn-cs"/>
+      </a:defRPr>
+    </a:lvl4pPr>
+    <a:lvl5pPr marL="1828800" algn="l" defTabSz="457200" rtl="0" eaLnBrk="1" latinLnBrk="0" hangingPunct="1">
+      <a:defRPr sz="1200" kern="1200">
+        <a:solidFill>
+          <a:schemeClr val="tx1"/>
+        </a:solidFill>
+        <a:latin typeface="+mn-lt"/>
+        <a:ea typeface="+mn-ea"/>
+        <a:cs typeface="+mn-cs"/>
+      </a:defRPr>
+    </a:lvl5pPr>
+    <a:lvl6pPr marL="2286000" algn="l" defTabSz="457200" rtl="0" eaLnBrk="1" latinLnBrk="0" hangingPunct="1">
+      <a:defRPr sz="1200" kern="1200">
+        <a:solidFill>
+          <a:schemeClr val="tx1"/>
+        </a:solidFill>
+        <a:latin typeface="+mn-lt"/>
+        <a:ea typeface="+mn-ea"/>
+        <a:cs typeface="+mn-cs"/>
+      </a:defRPr>
+    </a:lvl6pPr>
+    <a:lvl7pPr marL="2743200" algn="l" defTabSz="457200" rtl="0" eaLnBrk="1" latinLnBrk="0" hangingPunct="1">
+      <a:defRPr sz="1200" kern="1200">
+        <a:solidFill>
+          <a:schemeClr val="tx1"/>
+        </a:solidFill>
+        <a:latin typeface="+mn-lt"/>
+        <a:ea typeface="+mn-ea"/>
+        <a:cs typeface="+mn-cs"/>
+      </a:defRPr>
+    </a:lvl7pPr>
+    <a:lvl8pPr marL="3200400" algn="l" defTabSz="457200" rtl="0" eaLnBrk="1" latinLnBrk="0" hangingPunct="1">
+      <a:defRPr sz="1200" kern="1200">
+        <a:solidFill>
+          <a:schemeClr val="tx1"/>
+        </a:solidFill>
+        <a:latin typeface="+mn-lt"/>
+        <a:ea typeface="+mn-ea"/>
+        <a:cs typeface="+mn-cs"/>
+      </a:defRPr>
+    </a:lvl8pPr>
+    <a:lvl9pPr marL="3657600" algn="l" defTabSz="457200" rtl="0" eaLnBrk="1" latinLnBrk="0" hangingPunct="1">
+      <a:defRPr sz="1200" kern="1200">
+        <a:solidFill>
+          <a:schemeClr val="tx1"/>
+        </a:solidFill>
+        <a:latin typeface="+mn-lt"/>
+        <a:ea typeface="+mn-ea"/>
+        <a:cs typeface="+mn-cs"/>
+      </a:defRPr>
+    </a:lvl9pPr>
+  </p:notesStyle>
+</p:notesMaster>
+</file>
+
+<file path=ppt/notesSlides/notesSlide1.xml><?xml version="1.0" encoding="utf-8"?>
+<p:notes xmlns:a="http://schemas.openxmlformats.org/drawingml/2006/main" xmlns:p="http://schemas.openxmlformats.org/presentationml/2006/main" xmlns:r="http://schemas.openxmlformats.org/officeDocument/2006/relationships">
+  <p:cSld>
+    <p:spTree>
+      <p:nvGrpSpPr>
+        <p:cNvPr id="1" name=""/>
+        <p:cNvGrpSpPr/>
+        <p:nvPr/>
+      </p:nvGrpSpPr>
+      <p:grpSpPr>
+        <a:xfrm>
+          <a:off x="0" y="0"/>
+          <a:ext cx="0" cy="0"/>
+          <a:chOff x="0" y="0"/>
+          <a:chExt cx="0" cy="0"/>
+        </a:xfrm>
+      </p:grpSpPr>
+      <p:sp>
+        <p:nvSpPr>
+          <p:cNvPr id="2" name="Slide Image Placeholder 1"/>
+          <p:cNvSpPr>
+            <a:spLocks noGrp="1"/>
+          </p:cNvSpPr>
+          <p:nvPr>
+            <p:ph type="sldImg" idx="2"/>
+          </p:nvPr>
+        </p:nvSpPr>
+        <p:spPr/>
+      </p:sp>
+      <p:sp>
+        <p:nvSpPr>
+          <p:cNvPr id="3" name="Notes Placeholder 2"/>
+          <p:cNvSpPr>
+            <a:spLocks noGrp="1"/>
+          </p:cNvSpPr>
+          <p:nvPr>
+            <p:ph type="body" idx="3" sz="quarter"/>
+          </p:nvPr>
+        </p:nvSpPr>
+        <p:spPr/>
+        <p:txBody>
+          <a:bodyPr/>
+          <a:lstStyle/>
+          <a:p>
+            <a:r>
+              <a:t>SPRECHER: Jan Kluth (Projektleiter)</a:t>
+            </a:r>
+          </a:p>
+          <a:p/>
+          <a:p>
+            <a:r>
+              <a:t>Guten Tag zusammen und herzlich willkommen zu unserer Projektpräsentation!</a:t>
+            </a:r>
+          </a:p>
+          <a:p/>
+          <a:p>
+            <a:r>
+              <a:t>Mein Name ist Jan Kluth, ich bin der Projektleiter dieses Vorhabens. Zusammen mit meinen Teamkollegen Mathias Vonau, Marian Bolecke, Marco Schmidt und Siyar von der NextLevel IT Solutions GmbH stellen wir Ihnen heute unser ganzheitliches Ausstattungskonzept für die Architektur- und Ingenieurgesellschaft VektorPlan GmbH vor.</a:t>
+            </a:r>
+          </a:p>
+          <a:p/>
+          <a:p>
+            <a:r>
+              <a:t>Ziel unseres Projektes war es, 16 hochmoderne, ergonomische Arbeitsplätze inklusive Serveranbindung und Druckinfrastruktur schlüsselfertig zu planen, zu kalkulieren und bereitzustellen.</a:t>
+            </a:r>
+          </a:p>
+        </p:txBody>
+      </p:sp>
+      <p:sp>
+        <p:nvSpPr>
+          <p:cNvPr id="4" name="Slide Number Placeholder 3"/>
+          <p:cNvSpPr>
+            <a:spLocks noGrp="1"/>
+          </p:cNvSpPr>
+          <p:nvPr>
+            <p:ph type="sldNum" idx="5" sz="quarter"/>
+          </p:nvPr>
+        </p:nvSpPr>
+        <p:spPr/>
+      </p:sp>
+    </p:spTree>
+  </p:cSld>
+  <p:clrMapOvr>
+    <a:masterClrMapping/>
+  </p:clrMapOvr>
+</p:notes>
+</file>
+
+<file path=ppt/notesSlides/notesSlide10.xml><?xml version="1.0" encoding="utf-8"?>
+<p:notes xmlns:a="http://schemas.openxmlformats.org/drawingml/2006/main" xmlns:p="http://schemas.openxmlformats.org/presentationml/2006/main" xmlns:r="http://schemas.openxmlformats.org/officeDocument/2006/relationships">
+  <p:cSld>
+    <p:spTree>
+      <p:nvGrpSpPr>
+        <p:cNvPr id="1" name=""/>
+        <p:cNvGrpSpPr/>
+        <p:nvPr/>
+      </p:nvGrpSpPr>
+      <p:grpSpPr>
+        <a:xfrm>
+          <a:off x="0" y="0"/>
+          <a:ext cx="0" cy="0"/>
+          <a:chOff x="0" y="0"/>
+          <a:chExt cx="0" cy="0"/>
+        </a:xfrm>
+      </p:grpSpPr>
+      <p:sp>
+        <p:nvSpPr>
+          <p:cNvPr id="2" name="Slide Image Placeholder 1"/>
+          <p:cNvSpPr>
+            <a:spLocks noGrp="1"/>
+          </p:cNvSpPr>
+          <p:nvPr>
+            <p:ph type="sldImg" idx="2"/>
+          </p:nvPr>
+        </p:nvSpPr>
+        <p:spPr/>
+      </p:sp>
+      <p:sp>
+        <p:nvSpPr>
+          <p:cNvPr id="3" name="Notes Placeholder 2"/>
+          <p:cNvSpPr>
+            <a:spLocks noGrp="1"/>
+          </p:cNvSpPr>
+          <p:nvPr>
+            <p:ph type="body" idx="3" sz="quarter"/>
+          </p:nvPr>
+        </p:nvSpPr>
+        <p:spPr/>
+        <p:txBody>
+          <a:bodyPr/>
+          <a:lstStyle/>
+          <a:p>
+            <a:r>
+              <a:t>SPRECHER: Marian Bolecke (Beschaffung &amp; Kalkulation)</a:t>
+            </a:r>
+          </a:p>
+          <a:p/>
+          <a:p>
+            <a:r>
+              <a:t>Hier sehen Sie unsere kaufmännische Vorwärtskalkulation nach klassischem IHK-Schema:</a:t>
+            </a:r>
+          </a:p>
+          <a:p/>
+          <a:p>
+            <a:r>
+              <a:t>Ausgehend von den Einkaufs-Bezugspreisen schlagen wir 25% Handlungskosten für Lager, Logistik und Bereitstellung auf, gefolgt von 12% unternehmerischem Gewinnzuschlag und 3% Kundenskonto 'im Hundert'.</a:t>
+            </a:r>
+          </a:p>
+          <a:p>
+            <a:r>
+              <a:t>Unser Gesamtangebot an VektorPlan beläuft sich auf 67.179,32 € netto bzw. 79.943,39 € brutto inklusive 1. Jahr aller Softwarelizenzen und der kompletten Vor-Ort-Montage. Ich übergebe nun an Siyar für die Berechnungen der Serverkapazität und Stromkosten!</a:t>
+            </a:r>
+          </a:p>
+        </p:txBody>
+      </p:sp>
+      <p:sp>
+        <p:nvSpPr>
+          <p:cNvPr id="4" name="Slide Number Placeholder 3"/>
+          <p:cNvSpPr>
+            <a:spLocks noGrp="1"/>
+          </p:cNvSpPr>
+          <p:nvPr>
+            <p:ph type="sldNum" idx="5" sz="quarter"/>
+          </p:nvPr>
+        </p:nvSpPr>
+        <p:spPr/>
+      </p:sp>
+    </p:spTree>
+  </p:cSld>
+  <p:clrMapOvr>
+    <a:masterClrMapping/>
+  </p:clrMapOvr>
+</p:notes>
+</file>
+
+<file path=ppt/notesSlides/notesSlide11.xml><?xml version="1.0" encoding="utf-8"?>
+<p:notes xmlns:a="http://schemas.openxmlformats.org/drawingml/2006/main" xmlns:p="http://schemas.openxmlformats.org/presentationml/2006/main" xmlns:r="http://schemas.openxmlformats.org/officeDocument/2006/relationships">
+  <p:cSld>
+    <p:spTree>
+      <p:nvGrpSpPr>
+        <p:cNvPr id="1" name=""/>
+        <p:cNvGrpSpPr/>
+        <p:nvPr/>
+      </p:nvGrpSpPr>
+      <p:grpSpPr>
+        <a:xfrm>
+          <a:off x="0" y="0"/>
+          <a:ext cx="0" cy="0"/>
+          <a:chOff x="0" y="0"/>
+          <a:chExt cx="0" cy="0"/>
+        </a:xfrm>
+      </p:grpSpPr>
+      <p:sp>
+        <p:nvSpPr>
+          <p:cNvPr id="2" name="Slide Image Placeholder 1"/>
+          <p:cNvSpPr>
+            <a:spLocks noGrp="1"/>
+          </p:cNvSpPr>
+          <p:nvPr>
+            <p:ph type="sldImg" idx="2"/>
+          </p:nvPr>
+        </p:nvSpPr>
+        <p:spPr/>
+      </p:sp>
+      <p:sp>
+        <p:nvSpPr>
+          <p:cNvPr id="3" name="Notes Placeholder 2"/>
+          <p:cNvSpPr>
+            <a:spLocks noGrp="1"/>
+          </p:cNvSpPr>
+          <p:nvPr>
+            <p:ph type="body" idx="3" sz="quarter"/>
+          </p:nvPr>
+        </p:nvSpPr>
+        <p:spPr/>
+        <p:txBody>
+          <a:bodyPr/>
+          <a:lstStyle/>
+          <a:p>
+            <a:r>
+              <a:t>SPRECHER: Siyar (Berechnungen &amp; Dokumentation)</a:t>
+            </a:r>
+          </a:p>
+          <a:p/>
+          <a:p>
+            <a:r>
+              <a:t>Hallo zusammen! Der Kunde hat uns im Vorfeld um zwei konkrete Berechnungen für seine Budgetplanung gebeten:</a:t>
+            </a:r>
+          </a:p>
+          <a:p/>
+          <a:p>
+            <a:r>
+              <a:t>Erstens der Speicherplatz auf dem Fileserver: Bei 16 Plätzen fallen täglich 350 MiB CAD-Daten an. Für ein Quartal mit 65 Arbeitstagen ergibt das 364.000 MiB. Geteilt durch den IEC-Binärfaktor 1.024 sind das 355,47 GiB. Aufgerundet auf volle GiB und mit dem geforderten Sicherheitszuschlag von 25% muss der Server für genau 445 GiB ausgelegt werden.</a:t>
+            </a:r>
+          </a:p>
+          <a:p/>
+          <a:p>
+            <a:r>
+              <a:t>Zweitens die Energiekosten: Die 12 Standard-PCs ziehen je 140 W, die 4 CAD-Rechner je 320 W. Zusammen sind das 2.960 W. Bei 220 Arbeitstagen à 8,5 Stunden Laufzeit verbrauchen alle 16 Plätze jährlich 5.535,2 kWh. Bei einem Strompreis von 0,32 € pro kWh entstehen Stromkosten von exakt 1.771,26 € im Jahr. Marco übernimmt nun die Qualitätssicherung!</a:t>
+            </a:r>
+          </a:p>
+        </p:txBody>
+      </p:sp>
+      <p:sp>
+        <p:nvSpPr>
+          <p:cNvPr id="4" name="Slide Number Placeholder 3"/>
+          <p:cNvSpPr>
+            <a:spLocks noGrp="1"/>
+          </p:cNvSpPr>
+          <p:nvPr>
+            <p:ph type="sldNum" idx="5" sz="quarter"/>
+          </p:nvPr>
+        </p:nvSpPr>
+        <p:spPr/>
+      </p:sp>
+    </p:spTree>
+  </p:cSld>
+  <p:clrMapOvr>
+    <a:masterClrMapping/>
+  </p:clrMapOvr>
+</p:notes>
+</file>
+
+<file path=ppt/notesSlides/notesSlide12.xml><?xml version="1.0" encoding="utf-8"?>
+<p:notes xmlns:a="http://schemas.openxmlformats.org/drawingml/2006/main" xmlns:p="http://schemas.openxmlformats.org/presentationml/2006/main" xmlns:r="http://schemas.openxmlformats.org/officeDocument/2006/relationships">
+  <p:cSld>
+    <p:spTree>
+      <p:nvGrpSpPr>
+        <p:cNvPr id="1" name=""/>
+        <p:cNvGrpSpPr/>
+        <p:nvPr/>
+      </p:nvGrpSpPr>
+      <p:grpSpPr>
+        <a:xfrm>
+          <a:off x="0" y="0"/>
+          <a:ext cx="0" cy="0"/>
+          <a:chOff x="0" y="0"/>
+          <a:chExt cx="0" cy="0"/>
+        </a:xfrm>
+      </p:grpSpPr>
+      <p:sp>
+        <p:nvSpPr>
+          <p:cNvPr id="2" name="Slide Image Placeholder 1"/>
+          <p:cNvSpPr>
+            <a:spLocks noGrp="1"/>
+          </p:cNvSpPr>
+          <p:nvPr>
+            <p:ph type="sldImg" idx="2"/>
+          </p:nvPr>
+        </p:nvSpPr>
+        <p:spPr/>
+      </p:sp>
+      <p:sp>
+        <p:nvSpPr>
+          <p:cNvPr id="3" name="Notes Placeholder 2"/>
+          <p:cNvSpPr>
+            <a:spLocks noGrp="1"/>
+          </p:cNvSpPr>
+          <p:nvPr>
+            <p:ph type="body" idx="3" sz="quarter"/>
+          </p:nvPr>
+        </p:nvSpPr>
+        <p:spPr/>
+        <p:txBody>
+          <a:bodyPr/>
+          <a:lstStyle/>
+          <a:p>
+            <a:r>
+              <a:t>SPRECHER: Marco Schmidt (Qualitätsmanagement &amp; Logistik)</a:t>
+            </a:r>
+          </a:p>
+          <a:p/>
+          <a:p>
+            <a:r>
+              <a:t>Danke Siyar! Als Qualitätsmanager trage ich die Verantwortung für Wareneingang und Compliance.</a:t>
+            </a:r>
+          </a:p>
+          <a:p/>
+          <a:p>
+            <a:r>
+              <a:t>Im Handelskauf nach § 377 HGB gilt eine strenge Rügepflicht: Wer Mängel nicht unverzüglich rügt, verliert seine Gewährleistung! In unserem Fallbeispiel gab es zwei Fehler: Ein Gehäuseschaden an einer Workstation und ein Monitor wurde falsch mit Full-HD geliefert. Wir haben sofort ein kaufmännisches Rüge-Schreiben nach DIN 5008 aufgesetzt und eine 14-tägige Frist zur Ersatzlieferung gesetzt.</a:t>
+            </a:r>
+          </a:p>
+          <a:p/>
+          <a:p>
+            <a:r>
+              <a:t>Auch beim Altdrucker haben wir höchste Standards angewandt: Entsorgung nach ElektroG, getrenntes Tonerrecycling und eine 3-fache BSI-Löschung des internen Druckerspeichers zum Schutz vertraulicher Baupläne.</a:t>
+            </a:r>
+          </a:p>
+        </p:txBody>
+      </p:sp>
+      <p:sp>
+        <p:nvSpPr>
+          <p:cNvPr id="4" name="Slide Number Placeholder 3"/>
+          <p:cNvSpPr>
+            <a:spLocks noGrp="1"/>
+          </p:cNvSpPr>
+          <p:nvPr>
+            <p:ph type="sldNum" idx="5" sz="quarter"/>
+          </p:nvPr>
+        </p:nvSpPr>
+        <p:spPr/>
+      </p:sp>
+    </p:spTree>
+  </p:cSld>
+  <p:clrMapOvr>
+    <a:masterClrMapping/>
+  </p:clrMapOvr>
+</p:notes>
+</file>
+
+<file path=ppt/notesSlides/notesSlide13.xml><?xml version="1.0" encoding="utf-8"?>
+<p:notes xmlns:a="http://schemas.openxmlformats.org/drawingml/2006/main" xmlns:p="http://schemas.openxmlformats.org/presentationml/2006/main" xmlns:r="http://schemas.openxmlformats.org/officeDocument/2006/relationships">
+  <p:cSld>
+    <p:spTree>
+      <p:nvGrpSpPr>
+        <p:cNvPr id="1" name=""/>
+        <p:cNvGrpSpPr/>
+        <p:nvPr/>
+      </p:nvGrpSpPr>
+      <p:grpSpPr>
+        <a:xfrm>
+          <a:off x="0" y="0"/>
+          <a:ext cx="0" cy="0"/>
+          <a:chOff x="0" y="0"/>
+          <a:chExt cx="0" cy="0"/>
+        </a:xfrm>
+      </p:grpSpPr>
+      <p:sp>
+        <p:nvSpPr>
+          <p:cNvPr id="2" name="Slide Image Placeholder 1"/>
+          <p:cNvSpPr>
+            <a:spLocks noGrp="1"/>
+          </p:cNvSpPr>
+          <p:nvPr>
+            <p:ph type="sldImg" idx="2"/>
+          </p:nvPr>
+        </p:nvSpPr>
+        <p:spPr/>
+      </p:sp>
+      <p:sp>
+        <p:nvSpPr>
+          <p:cNvPr id="3" name="Notes Placeholder 2"/>
+          <p:cNvSpPr>
+            <a:spLocks noGrp="1"/>
+          </p:cNvSpPr>
+          <p:nvPr>
+            <p:ph type="body" idx="3" sz="quarter"/>
+          </p:nvPr>
+        </p:nvSpPr>
+        <p:spPr/>
+        <p:txBody>
+          <a:bodyPr/>
+          <a:lstStyle/>
+          <a:p>
+            <a:r>
+              <a:t>SPRECHER: Marco Schmidt (Qualitätsmanagement &amp; Logistik)</a:t>
+            </a:r>
+          </a:p>
+          <a:p/>
+          <a:p>
+            <a:r>
+              <a:t>Hier sehen Sie die 4 Phasen unseres Rollouts:</a:t>
+            </a:r>
+          </a:p>
+          <a:p/>
+          <a:p>
+            <a:r>
+              <a:t>Entscheidend für den reibungslosen Ablauf war Phase 1: Die Vorinstallation in unserem Systemhaus-Labor. Alle 16 PCs wurden über standardisierte Images betankt, lizenziert und 24 Stunden lang getestet. Beim Kunden vor Ort ging es dann nur noch um den Aufbau, ergonomische Justierung nach Bildschirmarbeitsverordnung, sauberes Kabelmanagement und die Endabnahme. Jan übernimmt nun wieder für den Soll-Ist-Vergleich und die Lessons Learned!</a:t>
+            </a:r>
+          </a:p>
+        </p:txBody>
+      </p:sp>
+      <p:sp>
+        <p:nvSpPr>
+          <p:cNvPr id="4" name="Slide Number Placeholder 3"/>
+          <p:cNvSpPr>
+            <a:spLocks noGrp="1"/>
+          </p:cNvSpPr>
+          <p:nvPr>
+            <p:ph type="sldNum" idx="5" sz="quarter"/>
+          </p:nvPr>
+        </p:nvSpPr>
+        <p:spPr/>
+      </p:sp>
+    </p:spTree>
+  </p:cSld>
+  <p:clrMapOvr>
+    <a:masterClrMapping/>
+  </p:clrMapOvr>
+</p:notes>
+</file>
+
+<file path=ppt/notesSlides/notesSlide14.xml><?xml version="1.0" encoding="utf-8"?>
+<p:notes xmlns:a="http://schemas.openxmlformats.org/drawingml/2006/main" xmlns:p="http://schemas.openxmlformats.org/presentationml/2006/main" xmlns:r="http://schemas.openxmlformats.org/officeDocument/2006/relationships">
+  <p:cSld>
+    <p:spTree>
+      <p:nvGrpSpPr>
+        <p:cNvPr id="1" name=""/>
+        <p:cNvGrpSpPr/>
+        <p:nvPr/>
+      </p:nvGrpSpPr>
+      <p:grpSpPr>
+        <a:xfrm>
+          <a:off x="0" y="0"/>
+          <a:ext cx="0" cy="0"/>
+          <a:chOff x="0" y="0"/>
+          <a:chExt cx="0" cy="0"/>
+        </a:xfrm>
+      </p:grpSpPr>
+      <p:sp>
+        <p:nvSpPr>
+          <p:cNvPr id="2" name="Slide Image Placeholder 1"/>
+          <p:cNvSpPr>
+            <a:spLocks noGrp="1"/>
+          </p:cNvSpPr>
+          <p:nvPr>
+            <p:ph type="sldImg" idx="2"/>
+          </p:nvPr>
+        </p:nvSpPr>
+        <p:spPr/>
+      </p:sp>
+      <p:sp>
+        <p:nvSpPr>
+          <p:cNvPr id="3" name="Notes Placeholder 2"/>
+          <p:cNvSpPr>
+            <a:spLocks noGrp="1"/>
+          </p:cNvSpPr>
+          <p:nvPr>
+            <p:ph type="body" idx="3" sz="quarter"/>
+          </p:nvPr>
+        </p:nvSpPr>
+        <p:spPr/>
+        <p:txBody>
+          <a:bodyPr/>
+          <a:lstStyle/>
+          <a:p>
+            <a:r>
+              <a:t>SPRECHER: Jan Kluth (Projektleiter)</a:t>
+            </a:r>
+          </a:p>
+          <a:p/>
+          <a:p>
+            <a:r>
+              <a:t>Kommen wir zum Projektergebnis im Soll-Ist-Vergleich:</a:t>
+            </a:r>
+          </a:p>
+          <a:p/>
+          <a:p>
+            <a:r>
+              <a:t>In der Zeitplanung waren 48 Tage vorgesehen – wir haben das Projekt in 46 Tagen übergeben, also 2 Tage vor dem Stichtag.</a:t>
+            </a:r>
+          </a:p>
+          <a:p>
+            <a:r>
+              <a:t>Im Budget hat der Kunde maximal 70.000 € freigegeben – unser Angebot lag bei 67.179 € netto. Der Kunde spart fast 3.000 €.</a:t>
+            </a:r>
+          </a:p>
+          <a:p>
+            <a:r>
+              <a:t>In der Qualität wurden alle 16 Arbeitsplätze ohne Vorbehalt abgenommen. Das Abnahmeprotokoll liegt rechtsgültig unterzeichnet vor.</a:t>
+            </a:r>
+          </a:p>
+        </p:txBody>
+      </p:sp>
+      <p:sp>
+        <p:nvSpPr>
+          <p:cNvPr id="4" name="Slide Number Placeholder 3"/>
+          <p:cNvSpPr>
+            <a:spLocks noGrp="1"/>
+          </p:cNvSpPr>
+          <p:nvPr>
+            <p:ph type="sldNum" idx="5" sz="quarter"/>
+          </p:nvPr>
+        </p:nvSpPr>
+        <p:spPr/>
+      </p:sp>
+    </p:spTree>
+  </p:cSld>
+  <p:clrMapOvr>
+    <a:masterClrMapping/>
+  </p:clrMapOvr>
+</p:notes>
+</file>
+
+<file path=ppt/notesSlides/notesSlide15.xml><?xml version="1.0" encoding="utf-8"?>
+<p:notes xmlns:a="http://schemas.openxmlformats.org/drawingml/2006/main" xmlns:p="http://schemas.openxmlformats.org/presentationml/2006/main" xmlns:r="http://schemas.openxmlformats.org/officeDocument/2006/relationships">
+  <p:cSld>
+    <p:spTree>
+      <p:nvGrpSpPr>
+        <p:cNvPr id="1" name=""/>
+        <p:cNvGrpSpPr/>
+        <p:nvPr/>
+      </p:nvGrpSpPr>
+      <p:grpSpPr>
+        <a:xfrm>
+          <a:off x="0" y="0"/>
+          <a:ext cx="0" cy="0"/>
+          <a:chOff x="0" y="0"/>
+          <a:chExt cx="0" cy="0"/>
+        </a:xfrm>
+      </p:grpSpPr>
+      <p:sp>
+        <p:nvSpPr>
+          <p:cNvPr id="2" name="Slide Image Placeholder 1"/>
+          <p:cNvSpPr>
+            <a:spLocks noGrp="1"/>
+          </p:cNvSpPr>
+          <p:nvPr>
+            <p:ph type="sldImg" idx="2"/>
+          </p:nvPr>
+        </p:nvSpPr>
+        <p:spPr/>
+      </p:sp>
+      <p:sp>
+        <p:nvSpPr>
+          <p:cNvPr id="3" name="Notes Placeholder 2"/>
+          <p:cNvSpPr>
+            <a:spLocks noGrp="1"/>
+          </p:cNvSpPr>
+          <p:nvPr>
+            <p:ph type="body" idx="3" sz="quarter"/>
+          </p:nvPr>
+        </p:nvSpPr>
+        <p:spPr/>
+        <p:txBody>
+          <a:bodyPr/>
+          <a:lstStyle/>
+          <a:p>
+            <a:r>
+              <a:t>SPRECHER: Jan Kluth (Projektleiter)</a:t>
+            </a:r>
+          </a:p>
+          <a:p/>
+          <a:p>
+            <a:r>
+              <a:t>Was sind unsere Lessons Learned aus diesem Projekt?</a:t>
+            </a:r>
+          </a:p>
+          <a:p/>
+          <a:p>
+            <a:r>
+              <a:t>Extrem positiv war die wissenschaftliche Nutzwertanalyse, die uns vor teuren Fehlentscheidungen bewahrt hat, sowie die strikte Wareneingangsprüfung. Für zukünftige Großprojekte haben wir mitgenommen, dass wir eine gemeinsame Begehung der Netzwerkdosen noch vor der Hardwarebestellung durchführen und immer 3 bis 5 Tage Puffer für RMA-Retouren im Zeitplan einplanen sollten.</a:t>
+            </a:r>
+          </a:p>
+        </p:txBody>
+      </p:sp>
+      <p:sp>
+        <p:nvSpPr>
+          <p:cNvPr id="4" name="Slide Number Placeholder 3"/>
+          <p:cNvSpPr>
+            <a:spLocks noGrp="1"/>
+          </p:cNvSpPr>
+          <p:nvPr>
+            <p:ph type="sldNum" idx="5" sz="quarter"/>
+          </p:nvPr>
+        </p:nvSpPr>
+        <p:spPr/>
+      </p:sp>
+    </p:spTree>
+  </p:cSld>
+  <p:clrMapOvr>
+    <a:masterClrMapping/>
+  </p:clrMapOvr>
+</p:notes>
+</file>
+
+<file path=ppt/notesSlides/notesSlide16.xml><?xml version="1.0" encoding="utf-8"?>
+<p:notes xmlns:a="http://schemas.openxmlformats.org/drawingml/2006/main" xmlns:p="http://schemas.openxmlformats.org/presentationml/2006/main" xmlns:r="http://schemas.openxmlformats.org/officeDocument/2006/relationships">
+  <p:cSld>
+    <p:spTree>
+      <p:nvGrpSpPr>
+        <p:cNvPr id="1" name=""/>
+        <p:cNvGrpSpPr/>
+        <p:nvPr/>
+      </p:nvGrpSpPr>
+      <p:grpSpPr>
+        <a:xfrm>
+          <a:off x="0" y="0"/>
+          <a:ext cx="0" cy="0"/>
+          <a:chOff x="0" y="0"/>
+          <a:chExt cx="0" cy="0"/>
+        </a:xfrm>
+      </p:grpSpPr>
+      <p:sp>
+        <p:nvSpPr>
+          <p:cNvPr id="2" name="Slide Image Placeholder 1"/>
+          <p:cNvSpPr>
+            <a:spLocks noGrp="1"/>
+          </p:cNvSpPr>
+          <p:nvPr>
+            <p:ph type="sldImg" idx="2"/>
+          </p:nvPr>
+        </p:nvSpPr>
+        <p:spPr/>
+      </p:sp>
+      <p:sp>
+        <p:nvSpPr>
+          <p:cNvPr id="3" name="Notes Placeholder 2"/>
+          <p:cNvSpPr>
+            <a:spLocks noGrp="1"/>
+          </p:cNvSpPr>
+          <p:nvPr>
+            <p:ph type="body" idx="3" sz="quarter"/>
+          </p:nvPr>
+        </p:nvSpPr>
+        <p:spPr/>
+        <p:txBody>
+          <a:bodyPr/>
+          <a:lstStyle/>
+          <a:p>
+            <a:r>
+              <a:t>SPRECHER: Jan Kluth (Projektleiter)</a:t>
+            </a:r>
+          </a:p>
+          <a:p/>
+          <a:p>
+            <a:r>
+              <a:t>Damit sind wir am Ende unserer Präsentation angelangt.</a:t>
+            </a:r>
+          </a:p>
+          <a:p/>
+          <a:p>
+            <a:r>
+              <a:t>Wir bedanken uns ganz herzlich für Ihre Aufmerksamkeit und stehen Ihnen nun sehr gerne für Fragen, technische Details und die gemeinsame Diskussion zur Verfügung!</a:t>
+            </a:r>
+          </a:p>
+        </p:txBody>
+      </p:sp>
+      <p:sp>
+        <p:nvSpPr>
+          <p:cNvPr id="4" name="Slide Number Placeholder 3"/>
+          <p:cNvSpPr>
+            <a:spLocks noGrp="1"/>
+          </p:cNvSpPr>
+          <p:nvPr>
+            <p:ph type="sldNum" idx="5" sz="quarter"/>
+          </p:nvPr>
+        </p:nvSpPr>
+        <p:spPr/>
+      </p:sp>
+    </p:spTree>
+  </p:cSld>
+  <p:clrMapOvr>
+    <a:masterClrMapping/>
+  </p:clrMapOvr>
+</p:notes>
+</file>
+
+<file path=ppt/notesSlides/notesSlide2.xml><?xml version="1.0" encoding="utf-8"?>
+<p:notes xmlns:a="http://schemas.openxmlformats.org/drawingml/2006/main" xmlns:p="http://schemas.openxmlformats.org/presentationml/2006/main" xmlns:r="http://schemas.openxmlformats.org/officeDocument/2006/relationships">
+  <p:cSld>
+    <p:spTree>
+      <p:nvGrpSpPr>
+        <p:cNvPr id="1" name=""/>
+        <p:cNvGrpSpPr/>
+        <p:nvPr/>
+      </p:nvGrpSpPr>
+      <p:grpSpPr>
+        <a:xfrm>
+          <a:off x="0" y="0"/>
+          <a:ext cx="0" cy="0"/>
+          <a:chOff x="0" y="0"/>
+          <a:chExt cx="0" cy="0"/>
+        </a:xfrm>
+      </p:grpSpPr>
+      <p:sp>
+        <p:nvSpPr>
+          <p:cNvPr id="2" name="Slide Image Placeholder 1"/>
+          <p:cNvSpPr>
+            <a:spLocks noGrp="1"/>
+          </p:cNvSpPr>
+          <p:nvPr>
+            <p:ph type="sldImg" idx="2"/>
+          </p:nvPr>
+        </p:nvSpPr>
+        <p:spPr/>
+      </p:sp>
+      <p:sp>
+        <p:nvSpPr>
+          <p:cNvPr id="3" name="Notes Placeholder 2"/>
+          <p:cNvSpPr>
+            <a:spLocks noGrp="1"/>
+          </p:cNvSpPr>
+          <p:nvPr>
+            <p:ph type="body" idx="3" sz="quarter"/>
+          </p:nvPr>
+        </p:nvSpPr>
+        <p:spPr/>
+        <p:txBody>
+          <a:bodyPr/>
+          <a:lstStyle/>
+          <a:p>
+            <a:r>
+              <a:t>SPRECHER: Jan Kluth (Projektleiter)</a:t>
+            </a:r>
+          </a:p>
+          <a:p/>
+          <a:p>
+            <a:r>
+              <a:t>Hier sehen Sie unsere Agenda für die heutigen 10 Minuten:</a:t>
+            </a:r>
+          </a:p>
+          <a:p/>
+          <a:p>
+            <a:r>
+              <a:t>Wir führen Sie durch den gesamten Projektlebenszyklus – von der ersten Kundenanalyse über die Projektstrukturierung nach DIN-Normen, die technische Produktauswahl und Vorwärtskalkulation bis hin zu den speziellen Kundenberechnungen, dem rechtssicheren Rollout und unserem abschließenden Soll-Ist-Vergleich. Jeder aus unserem Team wird dabei seinen fachlichen Schwerpunkt persönlich präsentieren.</a:t>
+            </a:r>
+          </a:p>
+        </p:txBody>
+      </p:sp>
+      <p:sp>
+        <p:nvSpPr>
+          <p:cNvPr id="4" name="Slide Number Placeholder 3"/>
+          <p:cNvSpPr>
+            <a:spLocks noGrp="1"/>
+          </p:cNvSpPr>
+          <p:nvPr>
+            <p:ph type="sldNum" idx="5" sz="quarter"/>
+          </p:nvPr>
+        </p:nvSpPr>
+        <p:spPr/>
+      </p:sp>
+    </p:spTree>
+  </p:cSld>
+  <p:clrMapOvr>
+    <a:masterClrMapping/>
+  </p:clrMapOvr>
+</p:notes>
+</file>
+
+<file path=ppt/notesSlides/notesSlide3.xml><?xml version="1.0" encoding="utf-8"?>
+<p:notes xmlns:a="http://schemas.openxmlformats.org/drawingml/2006/main" xmlns:p="http://schemas.openxmlformats.org/presentationml/2006/main" xmlns:r="http://schemas.openxmlformats.org/officeDocument/2006/relationships">
+  <p:cSld>
+    <p:spTree>
+      <p:nvGrpSpPr>
+        <p:cNvPr id="1" name=""/>
+        <p:cNvGrpSpPr/>
+        <p:nvPr/>
+      </p:nvGrpSpPr>
+      <p:grpSpPr>
+        <a:xfrm>
+          <a:off x="0" y="0"/>
+          <a:ext cx="0" cy="0"/>
+          <a:chOff x="0" y="0"/>
+          <a:chExt cx="0" cy="0"/>
+        </a:xfrm>
+      </p:grpSpPr>
+      <p:sp>
+        <p:nvSpPr>
+          <p:cNvPr id="2" name="Slide Image Placeholder 1"/>
+          <p:cNvSpPr>
+            <a:spLocks noGrp="1"/>
+          </p:cNvSpPr>
+          <p:nvPr>
+            <p:ph type="sldImg" idx="2"/>
+          </p:nvPr>
+        </p:nvSpPr>
+        <p:spPr/>
+      </p:sp>
+      <p:sp>
+        <p:nvSpPr>
+          <p:cNvPr id="3" name="Notes Placeholder 2"/>
+          <p:cNvSpPr>
+            <a:spLocks noGrp="1"/>
+          </p:cNvSpPr>
+          <p:nvPr>
+            <p:ph type="body" idx="3" sz="quarter"/>
+          </p:nvPr>
+        </p:nvSpPr>
+        <p:spPr/>
+        <p:txBody>
+          <a:bodyPr/>
+          <a:lstStyle/>
+          <a:p>
+            <a:r>
+              <a:t>SPRECHER: Jan Kluth (Projektleiter)</a:t>
+            </a:r>
+          </a:p>
+          <a:p/>
+          <a:p>
+            <a:r>
+              <a:t>Schauen wir auf die Ausgangssituation: Unser Kunde, die VektorPlan GmbH, modernisiert zwei Großraumbüros und richtet eine Plotterstation ein.</a:t>
+            </a:r>
+          </a:p>
+          <a:p/>
+          <a:p>
+            <a:r>
+              <a:t>Die Mitarbeiter in der Bauleitung brauchten zuverlässige, leise Rechner. Die Konstrukteure hingegen stießen bei 3D-BIM-Modellen an massive Leistungsgrenzen.</a:t>
+            </a:r>
+          </a:p>
+          <a:p>
+            <a:r>
+              <a:t>Deshalb lautete der klare Auftrag an uns: 12 Standard-PCs, 4 High-End-Workstations, Doppelbildschirme für jeden der 16 Plätze, mobile Zwischensicherungs-SSDs und ein zentrales DIN-A3-Farblasergerät – schlüsselfertig montiert und getestet.</a:t>
+            </a:r>
+          </a:p>
+        </p:txBody>
+      </p:sp>
+      <p:sp>
+        <p:nvSpPr>
+          <p:cNvPr id="4" name="Slide Number Placeholder 3"/>
+          <p:cNvSpPr>
+            <a:spLocks noGrp="1"/>
+          </p:cNvSpPr>
+          <p:nvPr>
+            <p:ph type="sldNum" idx="5" sz="quarter"/>
+          </p:nvPr>
+        </p:nvSpPr>
+        <p:spPr/>
+      </p:sp>
+    </p:spTree>
+  </p:cSld>
+  <p:clrMapOvr>
+    <a:masterClrMapping/>
+  </p:clrMapOvr>
+</p:notes>
+</file>
+
+<file path=ppt/notesSlides/notesSlide4.xml><?xml version="1.0" encoding="utf-8"?>
+<p:notes xmlns:a="http://schemas.openxmlformats.org/drawingml/2006/main" xmlns:p="http://schemas.openxmlformats.org/presentationml/2006/main" xmlns:r="http://schemas.openxmlformats.org/officeDocument/2006/relationships">
+  <p:cSld>
+    <p:spTree>
+      <p:nvGrpSpPr>
+        <p:cNvPr id="1" name=""/>
+        <p:cNvGrpSpPr/>
+        <p:nvPr/>
+      </p:nvGrpSpPr>
+      <p:grpSpPr>
+        <a:xfrm>
+          <a:off x="0" y="0"/>
+          <a:ext cx="0" cy="0"/>
+          <a:chOff x="0" y="0"/>
+          <a:chExt cx="0" cy="0"/>
+        </a:xfrm>
+      </p:grpSpPr>
+      <p:sp>
+        <p:nvSpPr>
+          <p:cNvPr id="2" name="Slide Image Placeholder 1"/>
+          <p:cNvSpPr>
+            <a:spLocks noGrp="1"/>
+          </p:cNvSpPr>
+          <p:nvPr>
+            <p:ph type="sldImg" idx="2"/>
+          </p:nvPr>
+        </p:nvSpPr>
+        <p:spPr/>
+      </p:sp>
+      <p:sp>
+        <p:nvSpPr>
+          <p:cNvPr id="3" name="Notes Placeholder 2"/>
+          <p:cNvSpPr>
+            <a:spLocks noGrp="1"/>
+          </p:cNvSpPr>
+          <p:nvPr>
+            <p:ph type="body" idx="3" sz="quarter"/>
+          </p:nvPr>
+        </p:nvSpPr>
+        <p:spPr/>
+        <p:txBody>
+          <a:bodyPr/>
+          <a:lstStyle/>
+          <a:p>
+            <a:r>
+              <a:t>SPRECHER: Jan Kluth (Projektleiter)</a:t>
+            </a:r>
+          </a:p>
+          <a:p/>
+          <a:p>
+            <a:r>
+              <a:t>Damit ein solches Projekt in Time und in Budget bleibt, haben wir die Rollen nach individuellen Stärken aufgeteilt:</a:t>
+            </a:r>
+          </a:p>
+          <a:p/>
+          <a:p>
+            <a:r>
+              <a:t>Ich habe die Gesamtleitung, Meilensteine und Kundenabstimmung übernommen. Mathias war unser technischer Architekt fürs Lastenheft und das Staging. Marian kümmerte sich um Einkaufspreise und kaufmännische Vorwärtskalkulation. Marco übernahm das Qualitätsmanagement mit § 377 HGB und Entsorgung, während Siyar für die mathematischen Kundenberechnungen und die Dokumentensicherung zuständig war. Ich übergebe nun an Mathias für die Struktur- und Ablaufplanung!</a:t>
+            </a:r>
+          </a:p>
+        </p:txBody>
+      </p:sp>
+      <p:sp>
+        <p:nvSpPr>
+          <p:cNvPr id="4" name="Slide Number Placeholder 3"/>
+          <p:cNvSpPr>
+            <a:spLocks noGrp="1"/>
+          </p:cNvSpPr>
+          <p:nvPr>
+            <p:ph type="sldNum" idx="5" sz="quarter"/>
+          </p:nvPr>
+        </p:nvSpPr>
+        <p:spPr/>
+      </p:sp>
+    </p:spTree>
+  </p:cSld>
+  <p:clrMapOvr>
+    <a:masterClrMapping/>
+  </p:clrMapOvr>
+</p:notes>
+</file>
+
+<file path=ppt/notesSlides/notesSlide5.xml><?xml version="1.0" encoding="utf-8"?>
+<p:notes xmlns:a="http://schemas.openxmlformats.org/drawingml/2006/main" xmlns:p="http://schemas.openxmlformats.org/presentationml/2006/main" xmlns:r="http://schemas.openxmlformats.org/officeDocument/2006/relationships">
+  <p:cSld>
+    <p:spTree>
+      <p:nvGrpSpPr>
+        <p:cNvPr id="1" name=""/>
+        <p:cNvGrpSpPr/>
+        <p:nvPr/>
+      </p:nvGrpSpPr>
+      <p:grpSpPr>
+        <a:xfrm>
+          <a:off x="0" y="0"/>
+          <a:ext cx="0" cy="0"/>
+          <a:chOff x="0" y="0"/>
+          <a:chExt cx="0" cy="0"/>
+        </a:xfrm>
+      </p:grpSpPr>
+      <p:sp>
+        <p:nvSpPr>
+          <p:cNvPr id="2" name="Slide Image Placeholder 1"/>
+          <p:cNvSpPr>
+            <a:spLocks noGrp="1"/>
+          </p:cNvSpPr>
+          <p:nvPr>
+            <p:ph type="sldImg" idx="2"/>
+          </p:nvPr>
+        </p:nvSpPr>
+        <p:spPr/>
+      </p:sp>
+      <p:sp>
+        <p:nvSpPr>
+          <p:cNvPr id="3" name="Notes Placeholder 2"/>
+          <p:cNvSpPr>
+            <a:spLocks noGrp="1"/>
+          </p:cNvSpPr>
+          <p:nvPr>
+            <p:ph type="body" idx="3" sz="quarter"/>
+          </p:nvPr>
+        </p:nvSpPr>
+        <p:spPr/>
+        <p:txBody>
+          <a:bodyPr/>
+          <a:lstStyle/>
+          <a:p>
+            <a:r>
+              <a:t>SPRECHER: Mathias Vonau (Technischer Planer)</a:t>
+            </a:r>
+          </a:p>
+          <a:p/>
+          <a:p>
+            <a:r>
+              <a:t>Hallo zusammen, hier sehen Sie unseren Projektstrukturplan nach DIN 69901.</a:t>
+            </a:r>
+          </a:p>
+          <a:p/>
+          <a:p>
+            <a:r>
+              <a:t>Als 'Plan der Pläne' gliedert er unser Projekt in fünf logische Säulen: Hardware, Software, Netzwerk/Server, Qualitätsmanagement und Rollout/Projektleitung. Insgesamt haben wir 28 konkrete Arbeitspakete definiert. Jeder Bereich hat einen festen Verantwortlichen. Das verhindert Kompetenzgerangel und stellt sicher, dass kein Detail – wie die Patchkabel oder die BSI-Löschung des Altdruckers – vergessen wird.</a:t>
+            </a:r>
+          </a:p>
+        </p:txBody>
+      </p:sp>
+      <p:sp>
+        <p:nvSpPr>
+          <p:cNvPr id="4" name="Slide Number Placeholder 3"/>
+          <p:cNvSpPr>
+            <a:spLocks noGrp="1"/>
+          </p:cNvSpPr>
+          <p:nvPr>
+            <p:ph type="sldNum" idx="5" sz="quarter"/>
+          </p:nvPr>
+        </p:nvSpPr>
+        <p:spPr/>
+      </p:sp>
+    </p:spTree>
+  </p:cSld>
+  <p:clrMapOvr>
+    <a:masterClrMapping/>
+  </p:clrMapOvr>
+</p:notes>
+</file>
+
+<file path=ppt/notesSlides/notesSlide6.xml><?xml version="1.0" encoding="utf-8"?>
+<p:notes xmlns:a="http://schemas.openxmlformats.org/drawingml/2006/main" xmlns:p="http://schemas.openxmlformats.org/presentationml/2006/main" xmlns:r="http://schemas.openxmlformats.org/officeDocument/2006/relationships">
+  <p:cSld>
+    <p:spTree>
+      <p:nvGrpSpPr>
+        <p:cNvPr id="1" name=""/>
+        <p:cNvGrpSpPr/>
+        <p:nvPr/>
+      </p:nvGrpSpPr>
+      <p:grpSpPr>
+        <a:xfrm>
+          <a:off x="0" y="0"/>
+          <a:ext cx="0" cy="0"/>
+          <a:chOff x="0" y="0"/>
+          <a:chExt cx="0" cy="0"/>
+        </a:xfrm>
+      </p:grpSpPr>
+      <p:sp>
+        <p:nvSpPr>
+          <p:cNvPr id="2" name="Slide Image Placeholder 1"/>
+          <p:cNvSpPr>
+            <a:spLocks noGrp="1"/>
+          </p:cNvSpPr>
+          <p:nvPr>
+            <p:ph type="sldImg" idx="2"/>
+          </p:nvPr>
+        </p:nvSpPr>
+        <p:spPr/>
+      </p:sp>
+      <p:sp>
+        <p:nvSpPr>
+          <p:cNvPr id="3" name="Notes Placeholder 2"/>
+          <p:cNvSpPr>
+            <a:spLocks noGrp="1"/>
+          </p:cNvSpPr>
+          <p:nvPr>
+            <p:ph type="body" idx="3" sz="quarter"/>
+          </p:nvPr>
+        </p:nvSpPr>
+        <p:spPr/>
+        <p:txBody>
+          <a:bodyPr/>
+          <a:lstStyle/>
+          <a:p>
+            <a:r>
+              <a:t>SPRECHER: Mathias Vonau (Technischer Planer)</a:t>
+            </a:r>
+          </a:p>
+          <a:p/>
+          <a:p>
+            <a:r>
+              <a:t>Auf dieser Folie sehen Sie unseren Netzplan nach DIN 69900.</a:t>
+            </a:r>
+          </a:p>
+          <a:p/>
+          <a:p>
+            <a:r>
+              <a:t>Durch Vorwärts- und Rückwärtsrechnung haben wir den kritischen Pfad mit einer Gesamtdauer von 46 Arbeitstagen ermittelt. Alle rot hinterlegten Vorgänge haben einen Gesamtpuffer von 0 – wenn sich hier etwas verzögert, verschiebt sich der Einzugstermin des Kunden.</a:t>
+            </a:r>
+          </a:p>
+          <a:p>
+            <a:r>
+              <a:t>Besonders interessant ist Vorgang 10: Die Altdruckerentsorgung läuft parallel zur Montage vor Ort und hat 1 Tag Puffer. Ich übergebe nun an Marian, der die Hardwareauswahl und Nutzwertanalyse vorstellt.</a:t>
+            </a:r>
+          </a:p>
+        </p:txBody>
+      </p:sp>
+      <p:sp>
+        <p:nvSpPr>
+          <p:cNvPr id="4" name="Slide Number Placeholder 3"/>
+          <p:cNvSpPr>
+            <a:spLocks noGrp="1"/>
+          </p:cNvSpPr>
+          <p:nvPr>
+            <p:ph type="sldNum" idx="5" sz="quarter"/>
+          </p:nvPr>
+        </p:nvSpPr>
+        <p:spPr/>
+      </p:sp>
+    </p:spTree>
+  </p:cSld>
+  <p:clrMapOvr>
+    <a:masterClrMapping/>
+  </p:clrMapOvr>
+</p:notes>
+</file>
+
+<file path=ppt/notesSlides/notesSlide7.xml><?xml version="1.0" encoding="utf-8"?>
+<p:notes xmlns:a="http://schemas.openxmlformats.org/drawingml/2006/main" xmlns:p="http://schemas.openxmlformats.org/presentationml/2006/main" xmlns:r="http://schemas.openxmlformats.org/officeDocument/2006/relationships">
+  <p:cSld>
+    <p:spTree>
+      <p:nvGrpSpPr>
+        <p:cNvPr id="1" name=""/>
+        <p:cNvGrpSpPr/>
+        <p:nvPr/>
+      </p:nvGrpSpPr>
+      <p:grpSpPr>
+        <a:xfrm>
+          <a:off x="0" y="0"/>
+          <a:ext cx="0" cy="0"/>
+          <a:chOff x="0" y="0"/>
+          <a:chExt cx="0" cy="0"/>
+        </a:xfrm>
+      </p:grpSpPr>
+      <p:sp>
+        <p:nvSpPr>
+          <p:cNvPr id="2" name="Slide Image Placeholder 1"/>
+          <p:cNvSpPr>
+            <a:spLocks noGrp="1"/>
+          </p:cNvSpPr>
+          <p:nvPr>
+            <p:ph type="sldImg" idx="2"/>
+          </p:nvPr>
+        </p:nvSpPr>
+        <p:spPr/>
+      </p:sp>
+      <p:sp>
+        <p:nvSpPr>
+          <p:cNvPr id="3" name="Notes Placeholder 2"/>
+          <p:cNvSpPr>
+            <a:spLocks noGrp="1"/>
+          </p:cNvSpPr>
+          <p:nvPr>
+            <p:ph type="body" idx="3" sz="quarter"/>
+          </p:nvPr>
+        </p:nvSpPr>
+        <p:spPr/>
+        <p:txBody>
+          <a:bodyPr/>
+          <a:lstStyle/>
+          <a:p>
+            <a:r>
+              <a:t>SPRECHER: Marian Bolecke (Beschaffung &amp; Kalkulation)</a:t>
+            </a:r>
+          </a:p>
+          <a:p/>
+          <a:p>
+            <a:r>
+              <a:t>Vielen Dank Mathias! Schauen wir uns die Hardware-Anforderungen im Detail an.</a:t>
+            </a:r>
+          </a:p>
+          <a:p/>
+          <a:p>
+            <a:r>
+              <a:t>Wir haben die 16 Plätze in zwei klare Nutzerprofile getrennt: Bei den 12 Standard-PCs stand Geräuschlosigkeit und ein kompaktes Gehäuse im Vordergrund – dafür reicht der i5 mit integrierter Grafikkarte vollkommen aus.</a:t>
+            </a:r>
+          </a:p>
+          <a:p>
+            <a:r>
+              <a:t>Bei den 4 CAD-Plätzen durfte es keine Kompromisse geben: 64 GB DDR5-RAM und eine ISV-zertifizierte Profi-Grafikkarte mit mindestens 16 bis 20 GB VRAM. Ergänzt wird das durch 32 WQHD-Monitore mit IPS-Black-Technologie, damit feine Architektur-Linien perfekt lesbar sind.</a:t>
+            </a:r>
+          </a:p>
+        </p:txBody>
+      </p:sp>
+      <p:sp>
+        <p:nvSpPr>
+          <p:cNvPr id="4" name="Slide Number Placeholder 3"/>
+          <p:cNvSpPr>
+            <a:spLocks noGrp="1"/>
+          </p:cNvSpPr>
+          <p:nvPr>
+            <p:ph type="sldNum" idx="5" sz="quarter"/>
+          </p:nvPr>
+        </p:nvSpPr>
+        <p:spPr/>
+      </p:sp>
+    </p:spTree>
+  </p:cSld>
+  <p:clrMapOvr>
+    <a:masterClrMapping/>
+  </p:clrMapOvr>
+</p:notes>
+</file>
+
+<file path=ppt/notesSlides/notesSlide8.xml><?xml version="1.0" encoding="utf-8"?>
+<p:notes xmlns:a="http://schemas.openxmlformats.org/drawingml/2006/main" xmlns:p="http://schemas.openxmlformats.org/presentationml/2006/main" xmlns:r="http://schemas.openxmlformats.org/officeDocument/2006/relationships">
+  <p:cSld>
+    <p:spTree>
+      <p:nvGrpSpPr>
+        <p:cNvPr id="1" name=""/>
+        <p:cNvGrpSpPr/>
+        <p:nvPr/>
+      </p:nvGrpSpPr>
+      <p:grpSpPr>
+        <a:xfrm>
+          <a:off x="0" y="0"/>
+          <a:ext cx="0" cy="0"/>
+          <a:chOff x="0" y="0"/>
+          <a:chExt cx="0" cy="0"/>
+        </a:xfrm>
+      </p:grpSpPr>
+      <p:sp>
+        <p:nvSpPr>
+          <p:cNvPr id="2" name="Slide Image Placeholder 1"/>
+          <p:cNvSpPr>
+            <a:spLocks noGrp="1"/>
+          </p:cNvSpPr>
+          <p:nvPr>
+            <p:ph type="sldImg" idx="2"/>
+          </p:nvPr>
+        </p:nvSpPr>
+        <p:spPr/>
+      </p:sp>
+      <p:sp>
+        <p:nvSpPr>
+          <p:cNvPr id="3" name="Notes Placeholder 2"/>
+          <p:cNvSpPr>
+            <a:spLocks noGrp="1"/>
+          </p:cNvSpPr>
+          <p:nvPr>
+            <p:ph type="body" idx="3" sz="quarter"/>
+          </p:nvPr>
+        </p:nvSpPr>
+        <p:spPr/>
+        <p:txBody>
+          <a:bodyPr/>
+          <a:lstStyle/>
+          <a:p>
+            <a:r>
+              <a:t>SPRECHER: Marian Bolecke (Beschaffung &amp; Kalkulation)</a:t>
+            </a:r>
+          </a:p>
+          <a:p/>
+          <a:p>
+            <a:r>
+              <a:t>Hier sehen Sie die konkreten Markenprodukte, die wir im IT-Fachhandel recherchiert haben:</a:t>
+            </a:r>
+          </a:p>
+          <a:p/>
+          <a:p>
+            <a:r>
+              <a:t>Für das Standard-Büro haben wir das Lenovo ThinkCentre M70s für 690 € netto ausgewählt. Für die CAD-Arbeitsplätze fiel die Wahl auf den Lenovo ThinkStation P3 Tower mit NVIDIA RTX 4000 Ada für 3.200 € netto. Bei den Monitoren setzen wir auf den Dell UltraSharp U2724D für 310 € und beim Drucker auf den Lexmark CX930dse für 2.200 €. Warum genau diese Produkte gewonnen haben, zeigt unsere wissenschaftliche Nutzwertanalyse auf der nächsten Folie.</a:t>
+            </a:r>
+          </a:p>
+        </p:txBody>
+      </p:sp>
+      <p:sp>
+        <p:nvSpPr>
+          <p:cNvPr id="4" name="Slide Number Placeholder 3"/>
+          <p:cNvSpPr>
+            <a:spLocks noGrp="1"/>
+          </p:cNvSpPr>
+          <p:nvPr>
+            <p:ph type="sldNum" idx="5" sz="quarter"/>
+          </p:nvPr>
+        </p:nvSpPr>
+        <p:spPr/>
+      </p:sp>
+    </p:spTree>
+  </p:cSld>
+  <p:clrMapOvr>
+    <a:masterClrMapping/>
+  </p:clrMapOvr>
+</p:notes>
+</file>
+
+<file path=ppt/notesSlides/notesSlide9.xml><?xml version="1.0" encoding="utf-8"?>
+<p:notes xmlns:a="http://schemas.openxmlformats.org/drawingml/2006/main" xmlns:p="http://schemas.openxmlformats.org/presentationml/2006/main" xmlns:r="http://schemas.openxmlformats.org/officeDocument/2006/relationships">
+  <p:cSld>
+    <p:spTree>
+      <p:nvGrpSpPr>
+        <p:cNvPr id="1" name=""/>
+        <p:cNvGrpSpPr/>
+        <p:nvPr/>
+      </p:nvGrpSpPr>
+      <p:grpSpPr>
+        <a:xfrm>
+          <a:off x="0" y="0"/>
+          <a:ext cx="0" cy="0"/>
+          <a:chOff x="0" y="0"/>
+          <a:chExt cx="0" cy="0"/>
+        </a:xfrm>
+      </p:grpSpPr>
+      <p:sp>
+        <p:nvSpPr>
+          <p:cNvPr id="2" name="Slide Image Placeholder 1"/>
+          <p:cNvSpPr>
+            <a:spLocks noGrp="1"/>
+          </p:cNvSpPr>
+          <p:nvPr>
+            <p:ph type="sldImg" idx="2"/>
+          </p:nvPr>
+        </p:nvSpPr>
+        <p:spPr/>
+      </p:sp>
+      <p:sp>
+        <p:nvSpPr>
+          <p:cNvPr id="3" name="Notes Placeholder 2"/>
+          <p:cNvSpPr>
+            <a:spLocks noGrp="1"/>
+          </p:cNvSpPr>
+          <p:nvPr>
+            <p:ph type="body" idx="3" sz="quarter"/>
+          </p:nvPr>
+        </p:nvSpPr>
+        <p:spPr/>
+        <p:txBody>
+          <a:bodyPr/>
+          <a:lstStyle/>
+          <a:p>
+            <a:r>
+              <a:t>SPRECHER: Marian Bolecke (Beschaffung &amp; Kalkulation)</a:t>
+            </a:r>
+          </a:p>
+          <a:p/>
+          <a:p>
+            <a:r>
+              <a:t>Um Bauchgefühl auszuschließen, haben wir zwei gewichtete Nutzwertanalysen durchgeführt:</a:t>
+            </a:r>
+          </a:p>
+          <a:p/>
+          <a:p>
+            <a:r>
+              <a:t>Bei den Workstations gewinnt Lenovo mit 8,70 Punkten. Warum? Weil die GPU-Performance für ein Architekturbüro mit 40% gewichtet ist – und die RTX 4000 Ada Generation mit 20 GB VRAM dem Dell mit älterer A4000 und 16 GB haushoch überlegen ist.</a:t>
+            </a:r>
+          </a:p>
+          <a:p>
+            <a:r>
+              <a:t>Bei den Monitoren gewinnt Dell mit 9,10 Punkten. EIZO ist zwar ergonomisch top, kostet aber 480 € statt 310 €. Bei 32 Stück summiert sich das auf 5.440 € Mehrpreis! Dell bietet dank IPS-Black sogar den besseren Kontrast für Planzeichnungen.</a:t>
+            </a:r>
+          </a:p>
+        </p:txBody>
+      </p:sp>
+      <p:sp>
+        <p:nvSpPr>
+          <p:cNvPr id="4" name="Slide Number Placeholder 3"/>
+          <p:cNvSpPr>
+            <a:spLocks noGrp="1"/>
+          </p:cNvSpPr>
+          <p:nvPr>
+            <p:ph type="sldNum" idx="5" sz="quarter"/>
+          </p:nvPr>
+        </p:nvSpPr>
+        <p:spPr/>
+      </p:sp>
+    </p:spTree>
+  </p:cSld>
+  <p:clrMapOvr>
+    <a:masterClrMapping/>
+  </p:clrMapOvr>
+</p:notes>
 </file>
 
 <file path=ppt/slideLayouts/slideLayout1.xml><?xml version="1.0" encoding="utf-8"?>
@@ -13522,116 +15237,40 @@
           </a:p>
         </p:txBody>
       </p:sp>
-      <p:sp>
-        <p:nvSpPr>
-          <p:cNvPr id="5" name="Rounded Rectangle 4"/>
-          <p:cNvSpPr/>
-          <p:nvPr/>
-        </p:nvSpPr>
-        <p:spPr>
-          <a:xfrm>
-            <a:off x="731520" y="1234440"/>
-            <a:ext cx="10698480" cy="502920"/>
-          </a:xfrm>
-          <a:prstGeom prst="roundRect">
-            <a:avLst/>
-          </a:prstGeom>
-          <a:solidFill>
-            <a:srgbClr val="FCE4D6"/>
-          </a:solidFill>
-          <a:ln>
-            <a:solidFill>
-              <a:srgbClr val="C00000"/>
-            </a:solidFill>
-          </a:ln>
-        </p:spPr>
-        <p:style>
-          <a:lnRef idx="1">
-            <a:schemeClr val="accent1"/>
-          </a:lnRef>
-          <a:fillRef idx="3">
-            <a:schemeClr val="accent1"/>
-          </a:fillRef>
-          <a:effectRef idx="2">
-            <a:schemeClr val="accent1"/>
-          </a:effectRef>
-          <a:fontRef idx="minor">
-            <a:schemeClr val="lt1"/>
-          </a:fontRef>
-        </p:style>
-        <p:txBody>
-          <a:bodyPr rtlCol="0" anchor="ctr"/>
-          <a:lstStyle/>
-          <a:p>
-            <a:pPr algn="ctr">
-              <a:defRPr sz="1050" b="1">
-                <a:solidFill>
-                  <a:srgbClr val="9C0006"/>
-                </a:solidFill>
-                <a:latin typeface="Calibri"/>
-              </a:defRPr>
-            </a:pPr>
-            <a:r>
-              <a:t>Kritischer Pfad (rot): V1 ➔ V2 ➔ V3 ➔ V4 ➔ V5 ➔ V6 ➔ V7 ➔ V8 ➔ V9 ➔ V11 ➔ V12 ➔ V13 ➔ V14  |  Gesamtdauer: 46 Arbeitstage</a:t>
-            </a:r>
-          </a:p>
-        </p:txBody>
-      </p:sp>
-      <p:sp>
-        <p:nvSpPr>
-          <p:cNvPr id="6" name="Rounded Rectangle 5"/>
-          <p:cNvSpPr/>
-          <p:nvPr/>
-        </p:nvSpPr>
-        <p:spPr>
-          <a:xfrm>
-            <a:off x="731520" y="1920240"/>
-            <a:ext cx="1691640" cy="1280160"/>
-          </a:xfrm>
-          <a:prstGeom prst="roundRect">
-            <a:avLst/>
-          </a:prstGeom>
-          <a:solidFill>
-            <a:srgbClr val="FEF2ED"/>
-          </a:solidFill>
-          <a:ln w="19050">
-            <a:solidFill>
-              <a:srgbClr val="C00000"/>
-            </a:solidFill>
-          </a:ln>
-        </p:spPr>
-        <p:style>
-          <a:lnRef idx="1">
-            <a:schemeClr val="accent1"/>
-          </a:lnRef>
-          <a:fillRef idx="3">
-            <a:schemeClr val="accent1"/>
-          </a:fillRef>
-          <a:effectRef idx="2">
-            <a:schemeClr val="accent1"/>
-          </a:effectRef>
-          <a:fontRef idx="minor">
-            <a:schemeClr val="lt1"/>
-          </a:fontRef>
-        </p:style>
-        <p:txBody>
-          <a:bodyPr rtlCol="0" anchor="ctr"/>
-          <a:lstStyle/>
-          <a:p>
-            <a:pPr algn="ctr"/>
-          </a:p>
-        </p:txBody>
-      </p:sp>
-      <p:sp>
-        <p:nvSpPr>
-          <p:cNvPr id="7" name="TextBox 6"/>
+      <p:pic>
+        <p:nvPicPr>
+          <p:cNvPr id="5" name="Picture 4" descr="Netzplan.png"/>
+          <p:cNvPicPr>
+            <a:picLocks noChangeAspect="1"/>
+          </p:cNvPicPr>
+          <p:nvPr/>
+        </p:nvPicPr>
+        <p:blipFill>
+          <a:blip r:embed="rId3"/>
+          <a:stretch>
+            <a:fillRect/>
+          </a:stretch>
+        </p:blipFill>
+        <p:spPr>
+          <a:xfrm>
+            <a:off x="1615287" y="1234440"/>
+            <a:ext cx="8961120" cy="4572000"/>
+          </a:xfrm>
+          <a:prstGeom prst="rect">
+            <a:avLst/>
+          </a:prstGeom>
+        </p:spPr>
+      </p:pic>
+      <p:sp>
+        <p:nvSpPr>
+          <p:cNvPr id="6" name="TextBox 5"/>
           <p:cNvSpPr txBox="1"/>
           <p:nvPr/>
         </p:nvSpPr>
         <p:spPr>
           <a:xfrm>
-            <a:off x="804672" y="1993392"/>
-            <a:ext cx="1545336" cy="1133856"/>
+            <a:off x="731520" y="5897880"/>
+            <a:ext cx="10728655" cy="411480"/>
           </a:xfrm>
           <a:prstGeom prst="rect">
             <a:avLst/>
@@ -13644,8 +15283,8 @@
           </a:bodyPr>
           <a:lstStyle/>
           <a:p>
-            <a:pPr>
-              <a:defRPr sz="1050" b="1">
+            <a:pPr algn="ctr">
+              <a:defRPr sz="1100" b="1">
                 <a:solidFill>
                   <a:srgbClr val="9C0006"/>
                 </a:solidFill>
@@ -13653,1460 +15292,7 @@
               </a:defRPr>
             </a:pPr>
             <a:r>
-              <a:t>V1: Kick-off</a:t>
-            </a:r>
-          </a:p>
-          <a:p>
-            <a:pPr>
-              <a:defRPr sz="950" b="1">
-                <a:solidFill>
-                  <a:srgbClr val="262626"/>
-                </a:solidFill>
-                <a:latin typeface="Calibri"/>
-              </a:defRPr>
-            </a:pPr>
-            <a:r>
-              <a:t>Dauer: 2 Tage</a:t>
-            </a:r>
-          </a:p>
-          <a:p>
-            <a:pPr>
-              <a:defRPr sz="850">
-                <a:solidFill>
-                  <a:srgbClr val="595959"/>
-                </a:solidFill>
-                <a:latin typeface="Calibri"/>
-              </a:defRPr>
-            </a:pPr>
-            <a:r>
-              <a:t>FAZ 0 | FEZ 2</a:t>
-            </a:r>
-          </a:p>
-          <a:p>
-            <a:pPr>
-              <a:defRPr sz="850" b="1">
-                <a:solidFill>
-                  <a:srgbClr val="C00000"/>
-                </a:solidFill>
-                <a:latin typeface="Calibri"/>
-              </a:defRPr>
-            </a:pPr>
-            <a:r>
-              <a:t>GP: 0 (Kritisch)</a:t>
-            </a:r>
-          </a:p>
-        </p:txBody>
-      </p:sp>
-      <p:sp>
-        <p:nvSpPr>
-          <p:cNvPr id="8" name="Rounded Rectangle 7"/>
-          <p:cNvSpPr/>
-          <p:nvPr/>
-        </p:nvSpPr>
-        <p:spPr>
-          <a:xfrm>
-            <a:off x="2542032" y="1920240"/>
-            <a:ext cx="1691640" cy="1280160"/>
-          </a:xfrm>
-          <a:prstGeom prst="roundRect">
-            <a:avLst/>
-          </a:prstGeom>
-          <a:solidFill>
-            <a:srgbClr val="FEF2ED"/>
-          </a:solidFill>
-          <a:ln w="19050">
-            <a:solidFill>
-              <a:srgbClr val="C00000"/>
-            </a:solidFill>
-          </a:ln>
-        </p:spPr>
-        <p:style>
-          <a:lnRef idx="1">
-            <a:schemeClr val="accent1"/>
-          </a:lnRef>
-          <a:fillRef idx="3">
-            <a:schemeClr val="accent1"/>
-          </a:fillRef>
-          <a:effectRef idx="2">
-            <a:schemeClr val="accent1"/>
-          </a:effectRef>
-          <a:fontRef idx="minor">
-            <a:schemeClr val="lt1"/>
-          </a:fontRef>
-        </p:style>
-        <p:txBody>
-          <a:bodyPr rtlCol="0" anchor="ctr"/>
-          <a:lstStyle/>
-          <a:p>
-            <a:pPr algn="ctr"/>
-          </a:p>
-        </p:txBody>
-      </p:sp>
-      <p:sp>
-        <p:nvSpPr>
-          <p:cNvPr id="9" name="TextBox 8"/>
-          <p:cNvSpPr txBox="1"/>
-          <p:nvPr/>
-        </p:nvSpPr>
-        <p:spPr>
-          <a:xfrm>
-            <a:off x="2615184" y="1993392"/>
-            <a:ext cx="1545336" cy="1133856"/>
-          </a:xfrm>
-          <a:prstGeom prst="rect">
-            <a:avLst/>
-          </a:prstGeom>
-          <a:noFill/>
-        </p:spPr>
-        <p:txBody>
-          <a:bodyPr wrap="square">
-            <a:spAutoFit/>
-          </a:bodyPr>
-          <a:lstStyle/>
-          <a:p>
-            <a:pPr>
-              <a:defRPr sz="1050" b="1">
-                <a:solidFill>
-                  <a:srgbClr val="9C0006"/>
-                </a:solidFill>
-                <a:latin typeface="Calibri"/>
-              </a:defRPr>
-            </a:pPr>
-            <a:r>
-              <a:t>V2: Lastenheft</a:t>
-            </a:r>
-          </a:p>
-          <a:p>
-            <a:pPr>
-              <a:defRPr sz="950" b="1">
-                <a:solidFill>
-                  <a:srgbClr val="262626"/>
-                </a:solidFill>
-                <a:latin typeface="Calibri"/>
-              </a:defRPr>
-            </a:pPr>
-            <a:r>
-              <a:t>Dauer: 5 Tage</a:t>
-            </a:r>
-          </a:p>
-          <a:p>
-            <a:pPr>
-              <a:defRPr sz="850">
-                <a:solidFill>
-                  <a:srgbClr val="595959"/>
-                </a:solidFill>
-                <a:latin typeface="Calibri"/>
-              </a:defRPr>
-            </a:pPr>
-            <a:r>
-              <a:t>FAZ 2 | FEZ 7</a:t>
-            </a:r>
-          </a:p>
-          <a:p>
-            <a:pPr>
-              <a:defRPr sz="850" b="1">
-                <a:solidFill>
-                  <a:srgbClr val="C00000"/>
-                </a:solidFill>
-                <a:latin typeface="Calibri"/>
-              </a:defRPr>
-            </a:pPr>
-            <a:r>
-              <a:t>GP: 0 (Kritisch)</a:t>
-            </a:r>
-          </a:p>
-        </p:txBody>
-      </p:sp>
-      <p:sp>
-        <p:nvSpPr>
-          <p:cNvPr id="10" name="Rounded Rectangle 9"/>
-          <p:cNvSpPr/>
-          <p:nvPr/>
-        </p:nvSpPr>
-        <p:spPr>
-          <a:xfrm>
-            <a:off x="4352544" y="1920240"/>
-            <a:ext cx="1691640" cy="1280160"/>
-          </a:xfrm>
-          <a:prstGeom prst="roundRect">
-            <a:avLst/>
-          </a:prstGeom>
-          <a:solidFill>
-            <a:srgbClr val="FEF2ED"/>
-          </a:solidFill>
-          <a:ln w="19050">
-            <a:solidFill>
-              <a:srgbClr val="C00000"/>
-            </a:solidFill>
-          </a:ln>
-        </p:spPr>
-        <p:style>
-          <a:lnRef idx="1">
-            <a:schemeClr val="accent1"/>
-          </a:lnRef>
-          <a:fillRef idx="3">
-            <a:schemeClr val="accent1"/>
-          </a:fillRef>
-          <a:effectRef idx="2">
-            <a:schemeClr val="accent1"/>
-          </a:effectRef>
-          <a:fontRef idx="minor">
-            <a:schemeClr val="lt1"/>
-          </a:fontRef>
-        </p:style>
-        <p:txBody>
-          <a:bodyPr rtlCol="0" anchor="ctr"/>
-          <a:lstStyle/>
-          <a:p>
-            <a:pPr algn="ctr"/>
-          </a:p>
-        </p:txBody>
-      </p:sp>
-      <p:sp>
-        <p:nvSpPr>
-          <p:cNvPr id="11" name="TextBox 10"/>
-          <p:cNvSpPr txBox="1"/>
-          <p:nvPr/>
-        </p:nvSpPr>
-        <p:spPr>
-          <a:xfrm>
-            <a:off x="4425696" y="1993392"/>
-            <a:ext cx="1545336" cy="1133856"/>
-          </a:xfrm>
-          <a:prstGeom prst="rect">
-            <a:avLst/>
-          </a:prstGeom>
-          <a:noFill/>
-        </p:spPr>
-        <p:txBody>
-          <a:bodyPr wrap="square">
-            <a:spAutoFit/>
-          </a:bodyPr>
-          <a:lstStyle/>
-          <a:p>
-            <a:pPr>
-              <a:defRPr sz="1050" b="1">
-                <a:solidFill>
-                  <a:srgbClr val="9C0006"/>
-                </a:solidFill>
-                <a:latin typeface="Calibri"/>
-              </a:defRPr>
-            </a:pPr>
-            <a:r>
-              <a:t>V3: Recherche</a:t>
-            </a:r>
-          </a:p>
-          <a:p>
-            <a:pPr>
-              <a:defRPr sz="950" b="1">
-                <a:solidFill>
-                  <a:srgbClr val="262626"/>
-                </a:solidFill>
-                <a:latin typeface="Calibri"/>
-              </a:defRPr>
-            </a:pPr>
-            <a:r>
-              <a:t>Dauer: 5 Tage</a:t>
-            </a:r>
-          </a:p>
-          <a:p>
-            <a:pPr>
-              <a:defRPr sz="850">
-                <a:solidFill>
-                  <a:srgbClr val="595959"/>
-                </a:solidFill>
-                <a:latin typeface="Calibri"/>
-              </a:defRPr>
-            </a:pPr>
-            <a:r>
-              <a:t>FAZ 7 | FEZ 12</a:t>
-            </a:r>
-          </a:p>
-          <a:p>
-            <a:pPr>
-              <a:defRPr sz="850" b="1">
-                <a:solidFill>
-                  <a:srgbClr val="C00000"/>
-                </a:solidFill>
-                <a:latin typeface="Calibri"/>
-              </a:defRPr>
-            </a:pPr>
-            <a:r>
-              <a:t>GP: 0 (Kritisch)</a:t>
-            </a:r>
-          </a:p>
-        </p:txBody>
-      </p:sp>
-      <p:sp>
-        <p:nvSpPr>
-          <p:cNvPr id="12" name="Rounded Rectangle 11"/>
-          <p:cNvSpPr/>
-          <p:nvPr/>
-        </p:nvSpPr>
-        <p:spPr>
-          <a:xfrm>
-            <a:off x="6163055" y="1920240"/>
-            <a:ext cx="1691640" cy="1280160"/>
-          </a:xfrm>
-          <a:prstGeom prst="roundRect">
-            <a:avLst/>
-          </a:prstGeom>
-          <a:solidFill>
-            <a:srgbClr val="FEF2ED"/>
-          </a:solidFill>
-          <a:ln w="19050">
-            <a:solidFill>
-              <a:srgbClr val="C00000"/>
-            </a:solidFill>
-          </a:ln>
-        </p:spPr>
-        <p:style>
-          <a:lnRef idx="1">
-            <a:schemeClr val="accent1"/>
-          </a:lnRef>
-          <a:fillRef idx="3">
-            <a:schemeClr val="accent1"/>
-          </a:fillRef>
-          <a:effectRef idx="2">
-            <a:schemeClr val="accent1"/>
-          </a:effectRef>
-          <a:fontRef idx="minor">
-            <a:schemeClr val="lt1"/>
-          </a:fontRef>
-        </p:style>
-        <p:txBody>
-          <a:bodyPr rtlCol="0" anchor="ctr"/>
-          <a:lstStyle/>
-          <a:p>
-            <a:pPr algn="ctr"/>
-          </a:p>
-        </p:txBody>
-      </p:sp>
-      <p:sp>
-        <p:nvSpPr>
-          <p:cNvPr id="13" name="TextBox 12"/>
-          <p:cNvSpPr txBox="1"/>
-          <p:nvPr/>
-        </p:nvSpPr>
-        <p:spPr>
-          <a:xfrm>
-            <a:off x="6236207" y="1993392"/>
-            <a:ext cx="1545336" cy="1133856"/>
-          </a:xfrm>
-          <a:prstGeom prst="rect">
-            <a:avLst/>
-          </a:prstGeom>
-          <a:noFill/>
-        </p:spPr>
-        <p:txBody>
-          <a:bodyPr wrap="square">
-            <a:spAutoFit/>
-          </a:bodyPr>
-          <a:lstStyle/>
-          <a:p>
-            <a:pPr>
-              <a:defRPr sz="1050" b="1">
-                <a:solidFill>
-                  <a:srgbClr val="9C0006"/>
-                </a:solidFill>
-                <a:latin typeface="Calibri"/>
-              </a:defRPr>
-            </a:pPr>
-            <a:r>
-              <a:t>V4: Nutzwert</a:t>
-            </a:r>
-          </a:p>
-          <a:p>
-            <a:pPr>
-              <a:defRPr sz="950" b="1">
-                <a:solidFill>
-                  <a:srgbClr val="262626"/>
-                </a:solidFill>
-                <a:latin typeface="Calibri"/>
-              </a:defRPr>
-            </a:pPr>
-            <a:r>
-              <a:t>Dauer: 3 Tage</a:t>
-            </a:r>
-          </a:p>
-          <a:p>
-            <a:pPr>
-              <a:defRPr sz="850">
-                <a:solidFill>
-                  <a:srgbClr val="595959"/>
-                </a:solidFill>
-                <a:latin typeface="Calibri"/>
-              </a:defRPr>
-            </a:pPr>
-            <a:r>
-              <a:t>FAZ 12 | FEZ 15</a:t>
-            </a:r>
-          </a:p>
-          <a:p>
-            <a:pPr>
-              <a:defRPr sz="850" b="1">
-                <a:solidFill>
-                  <a:srgbClr val="C00000"/>
-                </a:solidFill>
-                <a:latin typeface="Calibri"/>
-              </a:defRPr>
-            </a:pPr>
-            <a:r>
-              <a:t>GP: 0 (Kritisch)</a:t>
-            </a:r>
-          </a:p>
-        </p:txBody>
-      </p:sp>
-      <p:sp>
-        <p:nvSpPr>
-          <p:cNvPr id="14" name="Rounded Rectangle 13"/>
-          <p:cNvSpPr/>
-          <p:nvPr/>
-        </p:nvSpPr>
-        <p:spPr>
-          <a:xfrm>
-            <a:off x="7973568" y="1920240"/>
-            <a:ext cx="1691640" cy="1280160"/>
-          </a:xfrm>
-          <a:prstGeom prst="roundRect">
-            <a:avLst/>
-          </a:prstGeom>
-          <a:solidFill>
-            <a:srgbClr val="FEF2ED"/>
-          </a:solidFill>
-          <a:ln w="19050">
-            <a:solidFill>
-              <a:srgbClr val="C00000"/>
-            </a:solidFill>
-          </a:ln>
-        </p:spPr>
-        <p:style>
-          <a:lnRef idx="1">
-            <a:schemeClr val="accent1"/>
-          </a:lnRef>
-          <a:fillRef idx="3">
-            <a:schemeClr val="accent1"/>
-          </a:fillRef>
-          <a:effectRef idx="2">
-            <a:schemeClr val="accent1"/>
-          </a:effectRef>
-          <a:fontRef idx="minor">
-            <a:schemeClr val="lt1"/>
-          </a:fontRef>
-        </p:style>
-        <p:txBody>
-          <a:bodyPr rtlCol="0" anchor="ctr"/>
-          <a:lstStyle/>
-          <a:p>
-            <a:pPr algn="ctr"/>
-          </a:p>
-        </p:txBody>
-      </p:sp>
-      <p:sp>
-        <p:nvSpPr>
-          <p:cNvPr id="15" name="TextBox 14"/>
-          <p:cNvSpPr txBox="1"/>
-          <p:nvPr/>
-        </p:nvSpPr>
-        <p:spPr>
-          <a:xfrm>
-            <a:off x="8046720" y="1993392"/>
-            <a:ext cx="1545336" cy="1133856"/>
-          </a:xfrm>
-          <a:prstGeom prst="rect">
-            <a:avLst/>
-          </a:prstGeom>
-          <a:noFill/>
-        </p:spPr>
-        <p:txBody>
-          <a:bodyPr wrap="square">
-            <a:spAutoFit/>
-          </a:bodyPr>
-          <a:lstStyle/>
-          <a:p>
-            <a:pPr>
-              <a:defRPr sz="1050" b="1">
-                <a:solidFill>
-                  <a:srgbClr val="9C0006"/>
-                </a:solidFill>
-                <a:latin typeface="Calibri"/>
-              </a:defRPr>
-            </a:pPr>
-            <a:r>
-              <a:t>V5: Angebot</a:t>
-            </a:r>
-          </a:p>
-          <a:p>
-            <a:pPr>
-              <a:defRPr sz="950" b="1">
-                <a:solidFill>
-                  <a:srgbClr val="262626"/>
-                </a:solidFill>
-                <a:latin typeface="Calibri"/>
-              </a:defRPr>
-            </a:pPr>
-            <a:r>
-              <a:t>Dauer: 4 Tage</a:t>
-            </a:r>
-          </a:p>
-          <a:p>
-            <a:pPr>
-              <a:defRPr sz="850">
-                <a:solidFill>
-                  <a:srgbClr val="595959"/>
-                </a:solidFill>
-                <a:latin typeface="Calibri"/>
-              </a:defRPr>
-            </a:pPr>
-            <a:r>
-              <a:t>FAZ 15 | FEZ 19</a:t>
-            </a:r>
-          </a:p>
-          <a:p>
-            <a:pPr>
-              <a:defRPr sz="850" b="1">
-                <a:solidFill>
-                  <a:srgbClr val="C00000"/>
-                </a:solidFill>
-                <a:latin typeface="Calibri"/>
-              </a:defRPr>
-            </a:pPr>
-            <a:r>
-              <a:t>GP: 0 (Kritisch)</a:t>
-            </a:r>
-          </a:p>
-        </p:txBody>
-      </p:sp>
-      <p:sp>
-        <p:nvSpPr>
-          <p:cNvPr id="16" name="Rounded Rectangle 15"/>
-          <p:cNvSpPr/>
-          <p:nvPr/>
-        </p:nvSpPr>
-        <p:spPr>
-          <a:xfrm>
-            <a:off x="9784080" y="1920240"/>
-            <a:ext cx="1691640" cy="1280160"/>
-          </a:xfrm>
-          <a:prstGeom prst="roundRect">
-            <a:avLst/>
-          </a:prstGeom>
-          <a:solidFill>
-            <a:srgbClr val="FEF2ED"/>
-          </a:solidFill>
-          <a:ln w="19050">
-            <a:solidFill>
-              <a:srgbClr val="C00000"/>
-            </a:solidFill>
-          </a:ln>
-        </p:spPr>
-        <p:style>
-          <a:lnRef idx="1">
-            <a:schemeClr val="accent1"/>
-          </a:lnRef>
-          <a:fillRef idx="3">
-            <a:schemeClr val="accent1"/>
-          </a:fillRef>
-          <a:effectRef idx="2">
-            <a:schemeClr val="accent1"/>
-          </a:effectRef>
-          <a:fontRef idx="minor">
-            <a:schemeClr val="lt1"/>
-          </a:fontRef>
-        </p:style>
-        <p:txBody>
-          <a:bodyPr rtlCol="0" anchor="ctr"/>
-          <a:lstStyle/>
-          <a:p>
-            <a:pPr algn="ctr"/>
-          </a:p>
-        </p:txBody>
-      </p:sp>
-      <p:sp>
-        <p:nvSpPr>
-          <p:cNvPr id="17" name="TextBox 16"/>
-          <p:cNvSpPr txBox="1"/>
-          <p:nvPr/>
-        </p:nvSpPr>
-        <p:spPr>
-          <a:xfrm>
-            <a:off x="9857232" y="1993392"/>
-            <a:ext cx="1545336" cy="1133856"/>
-          </a:xfrm>
-          <a:prstGeom prst="rect">
-            <a:avLst/>
-          </a:prstGeom>
-          <a:noFill/>
-        </p:spPr>
-        <p:txBody>
-          <a:bodyPr wrap="square">
-            <a:spAutoFit/>
-          </a:bodyPr>
-          <a:lstStyle/>
-          <a:p>
-            <a:pPr>
-              <a:defRPr sz="1050" b="1">
-                <a:solidFill>
-                  <a:srgbClr val="9C0006"/>
-                </a:solidFill>
-                <a:latin typeface="Calibri"/>
-              </a:defRPr>
-            </a:pPr>
-            <a:r>
-              <a:t>V6: Freigabe</a:t>
-            </a:r>
-          </a:p>
-          <a:p>
-            <a:pPr>
-              <a:defRPr sz="950" b="1">
-                <a:solidFill>
-                  <a:srgbClr val="262626"/>
-                </a:solidFill>
-                <a:latin typeface="Calibri"/>
-              </a:defRPr>
-            </a:pPr>
-            <a:r>
-              <a:t>Dauer: 3 Tage</a:t>
-            </a:r>
-          </a:p>
-          <a:p>
-            <a:pPr>
-              <a:defRPr sz="850">
-                <a:solidFill>
-                  <a:srgbClr val="595959"/>
-                </a:solidFill>
-                <a:latin typeface="Calibri"/>
-              </a:defRPr>
-            </a:pPr>
-            <a:r>
-              <a:t>FAZ 19 | FEZ 22</a:t>
-            </a:r>
-          </a:p>
-          <a:p>
-            <a:pPr>
-              <a:defRPr sz="850" b="1">
-                <a:solidFill>
-                  <a:srgbClr val="C00000"/>
-                </a:solidFill>
-                <a:latin typeface="Calibri"/>
-              </a:defRPr>
-            </a:pPr>
-            <a:r>
-              <a:t>GP: 0 (Kritisch)</a:t>
-            </a:r>
-          </a:p>
-        </p:txBody>
-      </p:sp>
-      <p:sp>
-        <p:nvSpPr>
-          <p:cNvPr id="18" name="Rounded Rectangle 17"/>
-          <p:cNvSpPr/>
-          <p:nvPr/>
-        </p:nvSpPr>
-        <p:spPr>
-          <a:xfrm>
-            <a:off x="731520" y="3566160"/>
-            <a:ext cx="1691640" cy="1280160"/>
-          </a:xfrm>
-          <a:prstGeom prst="roundRect">
-            <a:avLst/>
-          </a:prstGeom>
-          <a:solidFill>
-            <a:srgbClr val="FEF2ED"/>
-          </a:solidFill>
-          <a:ln w="19050">
-            <a:solidFill>
-              <a:srgbClr val="C00000"/>
-            </a:solidFill>
-          </a:ln>
-        </p:spPr>
-        <p:style>
-          <a:lnRef idx="1">
-            <a:schemeClr val="accent1"/>
-          </a:lnRef>
-          <a:fillRef idx="3">
-            <a:schemeClr val="accent1"/>
-          </a:fillRef>
-          <a:effectRef idx="2">
-            <a:schemeClr val="accent1"/>
-          </a:effectRef>
-          <a:fontRef idx="minor">
-            <a:schemeClr val="lt1"/>
-          </a:fontRef>
-        </p:style>
-        <p:txBody>
-          <a:bodyPr rtlCol="0" anchor="ctr"/>
-          <a:lstStyle/>
-          <a:p>
-            <a:pPr algn="ctr"/>
-          </a:p>
-        </p:txBody>
-      </p:sp>
-      <p:sp>
-        <p:nvSpPr>
-          <p:cNvPr id="19" name="TextBox 18"/>
-          <p:cNvSpPr txBox="1"/>
-          <p:nvPr/>
-        </p:nvSpPr>
-        <p:spPr>
-          <a:xfrm>
-            <a:off x="804672" y="3639312"/>
-            <a:ext cx="1545336" cy="1133856"/>
-          </a:xfrm>
-          <a:prstGeom prst="rect">
-            <a:avLst/>
-          </a:prstGeom>
-          <a:noFill/>
-        </p:spPr>
-        <p:txBody>
-          <a:bodyPr wrap="square">
-            <a:spAutoFit/>
-          </a:bodyPr>
-          <a:lstStyle/>
-          <a:p>
-            <a:pPr>
-              <a:defRPr sz="1050" b="1">
-                <a:solidFill>
-                  <a:srgbClr val="9C0006"/>
-                </a:solidFill>
-                <a:latin typeface="Calibri"/>
-              </a:defRPr>
-            </a:pPr>
-            <a:r>
-              <a:t>V7: Beschaffung</a:t>
-            </a:r>
-          </a:p>
-          <a:p>
-            <a:pPr>
-              <a:defRPr sz="950" b="1">
-                <a:solidFill>
-                  <a:srgbClr val="262626"/>
-                </a:solidFill>
-                <a:latin typeface="Calibri"/>
-              </a:defRPr>
-            </a:pPr>
-            <a:r>
-              <a:t>Dauer: 10 Tage</a:t>
-            </a:r>
-          </a:p>
-          <a:p>
-            <a:pPr>
-              <a:defRPr sz="850">
-                <a:solidFill>
-                  <a:srgbClr val="595959"/>
-                </a:solidFill>
-                <a:latin typeface="Calibri"/>
-              </a:defRPr>
-            </a:pPr>
-            <a:r>
-              <a:t>FAZ 22 | FEZ 32</a:t>
-            </a:r>
-          </a:p>
-          <a:p>
-            <a:pPr>
-              <a:defRPr sz="850" b="1">
-                <a:solidFill>
-                  <a:srgbClr val="C00000"/>
-                </a:solidFill>
-                <a:latin typeface="Calibri"/>
-              </a:defRPr>
-            </a:pPr>
-            <a:r>
-              <a:t>GP: 0 (Kritisch)</a:t>
-            </a:r>
-          </a:p>
-        </p:txBody>
-      </p:sp>
-      <p:sp>
-        <p:nvSpPr>
-          <p:cNvPr id="20" name="Rounded Rectangle 19"/>
-          <p:cNvSpPr/>
-          <p:nvPr/>
-        </p:nvSpPr>
-        <p:spPr>
-          <a:xfrm>
-            <a:off x="2542032" y="3566160"/>
-            <a:ext cx="1691640" cy="1280160"/>
-          </a:xfrm>
-          <a:prstGeom prst="roundRect">
-            <a:avLst/>
-          </a:prstGeom>
-          <a:solidFill>
-            <a:srgbClr val="FEF2ED"/>
-          </a:solidFill>
-          <a:ln w="19050">
-            <a:solidFill>
-              <a:srgbClr val="C00000"/>
-            </a:solidFill>
-          </a:ln>
-        </p:spPr>
-        <p:style>
-          <a:lnRef idx="1">
-            <a:schemeClr val="accent1"/>
-          </a:lnRef>
-          <a:fillRef idx="3">
-            <a:schemeClr val="accent1"/>
-          </a:fillRef>
-          <a:effectRef idx="2">
-            <a:schemeClr val="accent1"/>
-          </a:effectRef>
-          <a:fontRef idx="minor">
-            <a:schemeClr val="lt1"/>
-          </a:fontRef>
-        </p:style>
-        <p:txBody>
-          <a:bodyPr rtlCol="0" anchor="ctr"/>
-          <a:lstStyle/>
-          <a:p>
-            <a:pPr algn="ctr"/>
-          </a:p>
-        </p:txBody>
-      </p:sp>
-      <p:sp>
-        <p:nvSpPr>
-          <p:cNvPr id="21" name="TextBox 20"/>
-          <p:cNvSpPr txBox="1"/>
-          <p:nvPr/>
-        </p:nvSpPr>
-        <p:spPr>
-          <a:xfrm>
-            <a:off x="2615184" y="3639312"/>
-            <a:ext cx="1545336" cy="1133856"/>
-          </a:xfrm>
-          <a:prstGeom prst="rect">
-            <a:avLst/>
-          </a:prstGeom>
-          <a:noFill/>
-        </p:spPr>
-        <p:txBody>
-          <a:bodyPr wrap="square">
-            <a:spAutoFit/>
-          </a:bodyPr>
-          <a:lstStyle/>
-          <a:p>
-            <a:pPr>
-              <a:defRPr sz="1050" b="1">
-                <a:solidFill>
-                  <a:srgbClr val="9C0006"/>
-                </a:solidFill>
-                <a:latin typeface="Calibri"/>
-              </a:defRPr>
-            </a:pPr>
-            <a:r>
-              <a:t>V8: Wareneingang</a:t>
-            </a:r>
-          </a:p>
-          <a:p>
-            <a:pPr>
-              <a:defRPr sz="950" b="1">
-                <a:solidFill>
-                  <a:srgbClr val="262626"/>
-                </a:solidFill>
-                <a:latin typeface="Calibri"/>
-              </a:defRPr>
-            </a:pPr>
-            <a:r>
-              <a:t>Dauer: 2 Tage</a:t>
-            </a:r>
-          </a:p>
-          <a:p>
-            <a:pPr>
-              <a:defRPr sz="850">
-                <a:solidFill>
-                  <a:srgbClr val="595959"/>
-                </a:solidFill>
-                <a:latin typeface="Calibri"/>
-              </a:defRPr>
-            </a:pPr>
-            <a:r>
-              <a:t>FAZ 32 | FEZ 34</a:t>
-            </a:r>
-          </a:p>
-          <a:p>
-            <a:pPr>
-              <a:defRPr sz="850" b="1">
-                <a:solidFill>
-                  <a:srgbClr val="C00000"/>
-                </a:solidFill>
-                <a:latin typeface="Calibri"/>
-              </a:defRPr>
-            </a:pPr>
-            <a:r>
-              <a:t>GP: 0 (Kritisch)</a:t>
-            </a:r>
-          </a:p>
-        </p:txBody>
-      </p:sp>
-      <p:sp>
-        <p:nvSpPr>
-          <p:cNvPr id="22" name="Rounded Rectangle 21"/>
-          <p:cNvSpPr/>
-          <p:nvPr/>
-        </p:nvSpPr>
-        <p:spPr>
-          <a:xfrm>
-            <a:off x="4352544" y="3566160"/>
-            <a:ext cx="1691640" cy="1280160"/>
-          </a:xfrm>
-          <a:prstGeom prst="roundRect">
-            <a:avLst/>
-          </a:prstGeom>
-          <a:solidFill>
-            <a:srgbClr val="FEF2ED"/>
-          </a:solidFill>
-          <a:ln w="19050">
-            <a:solidFill>
-              <a:srgbClr val="C00000"/>
-            </a:solidFill>
-          </a:ln>
-        </p:spPr>
-        <p:style>
-          <a:lnRef idx="1">
-            <a:schemeClr val="accent1"/>
-          </a:lnRef>
-          <a:fillRef idx="3">
-            <a:schemeClr val="accent1"/>
-          </a:fillRef>
-          <a:effectRef idx="2">
-            <a:schemeClr val="accent1"/>
-          </a:effectRef>
-          <a:fontRef idx="minor">
-            <a:schemeClr val="lt1"/>
-          </a:fontRef>
-        </p:style>
-        <p:txBody>
-          <a:bodyPr rtlCol="0" anchor="ctr"/>
-          <a:lstStyle/>
-          <a:p>
-            <a:pPr algn="ctr"/>
-          </a:p>
-        </p:txBody>
-      </p:sp>
-      <p:sp>
-        <p:nvSpPr>
-          <p:cNvPr id="23" name="TextBox 22"/>
-          <p:cNvSpPr txBox="1"/>
-          <p:nvPr/>
-        </p:nvSpPr>
-        <p:spPr>
-          <a:xfrm>
-            <a:off x="4425696" y="3639312"/>
-            <a:ext cx="1545336" cy="1133856"/>
-          </a:xfrm>
-          <a:prstGeom prst="rect">
-            <a:avLst/>
-          </a:prstGeom>
-          <a:noFill/>
-        </p:spPr>
-        <p:txBody>
-          <a:bodyPr wrap="square">
-            <a:spAutoFit/>
-          </a:bodyPr>
-          <a:lstStyle/>
-          <a:p>
-            <a:pPr>
-              <a:defRPr sz="1050" b="1">
-                <a:solidFill>
-                  <a:srgbClr val="9C0006"/>
-                </a:solidFill>
-                <a:latin typeface="Calibri"/>
-              </a:defRPr>
-            </a:pPr>
-            <a:r>
-              <a:t>V9: Staging</a:t>
-            </a:r>
-          </a:p>
-          <a:p>
-            <a:pPr>
-              <a:defRPr sz="950" b="1">
-                <a:solidFill>
-                  <a:srgbClr val="262626"/>
-                </a:solidFill>
-                <a:latin typeface="Calibri"/>
-              </a:defRPr>
-            </a:pPr>
-            <a:r>
-              <a:t>Dauer: 5 Tage</a:t>
-            </a:r>
-          </a:p>
-          <a:p>
-            <a:pPr>
-              <a:defRPr sz="850">
-                <a:solidFill>
-                  <a:srgbClr val="595959"/>
-                </a:solidFill>
-                <a:latin typeface="Calibri"/>
-              </a:defRPr>
-            </a:pPr>
-            <a:r>
-              <a:t>FAZ 34 | FEZ 39</a:t>
-            </a:r>
-          </a:p>
-          <a:p>
-            <a:pPr>
-              <a:defRPr sz="850" b="1">
-                <a:solidFill>
-                  <a:srgbClr val="C00000"/>
-                </a:solidFill>
-                <a:latin typeface="Calibri"/>
-              </a:defRPr>
-            </a:pPr>
-            <a:r>
-              <a:t>GP: 0 (Kritisch)</a:t>
-            </a:r>
-          </a:p>
-        </p:txBody>
-      </p:sp>
-      <p:sp>
-        <p:nvSpPr>
-          <p:cNvPr id="24" name="Rounded Rectangle 23"/>
-          <p:cNvSpPr/>
-          <p:nvPr/>
-        </p:nvSpPr>
-        <p:spPr>
-          <a:xfrm>
-            <a:off x="6163055" y="3566160"/>
-            <a:ext cx="1691640" cy="1280160"/>
-          </a:xfrm>
-          <a:prstGeom prst="roundRect">
-            <a:avLst/>
-          </a:prstGeom>
-          <a:solidFill>
-            <a:srgbClr val="FEF2ED"/>
-          </a:solidFill>
-          <a:ln w="19050">
-            <a:solidFill>
-              <a:srgbClr val="C00000"/>
-            </a:solidFill>
-          </a:ln>
-        </p:spPr>
-        <p:style>
-          <a:lnRef idx="1">
-            <a:schemeClr val="accent1"/>
-          </a:lnRef>
-          <a:fillRef idx="3">
-            <a:schemeClr val="accent1"/>
-          </a:fillRef>
-          <a:effectRef idx="2">
-            <a:schemeClr val="accent1"/>
-          </a:effectRef>
-          <a:fontRef idx="minor">
-            <a:schemeClr val="lt1"/>
-          </a:fontRef>
-        </p:style>
-        <p:txBody>
-          <a:bodyPr rtlCol="0" anchor="ctr"/>
-          <a:lstStyle/>
-          <a:p>
-            <a:pPr algn="ctr"/>
-          </a:p>
-        </p:txBody>
-      </p:sp>
-      <p:sp>
-        <p:nvSpPr>
-          <p:cNvPr id="25" name="TextBox 24"/>
-          <p:cNvSpPr txBox="1"/>
-          <p:nvPr/>
-        </p:nvSpPr>
-        <p:spPr>
-          <a:xfrm>
-            <a:off x="6236207" y="3639312"/>
-            <a:ext cx="1545336" cy="1133856"/>
-          </a:xfrm>
-          <a:prstGeom prst="rect">
-            <a:avLst/>
-          </a:prstGeom>
-          <a:noFill/>
-        </p:spPr>
-        <p:txBody>
-          <a:bodyPr wrap="square">
-            <a:spAutoFit/>
-          </a:bodyPr>
-          <a:lstStyle/>
-          <a:p>
-            <a:pPr>
-              <a:defRPr sz="1050" b="1">
-                <a:solidFill>
-                  <a:srgbClr val="9C0006"/>
-                </a:solidFill>
-                <a:latin typeface="Calibri"/>
-              </a:defRPr>
-            </a:pPr>
-            <a:r>
-              <a:t>V11: Montage</a:t>
-            </a:r>
-          </a:p>
-          <a:p>
-            <a:pPr>
-              <a:defRPr sz="950" b="1">
-                <a:solidFill>
-                  <a:srgbClr val="262626"/>
-                </a:solidFill>
-                <a:latin typeface="Calibri"/>
-              </a:defRPr>
-            </a:pPr>
-            <a:r>
-              <a:t>Dauer: 3 Tage</a:t>
-            </a:r>
-          </a:p>
-          <a:p>
-            <a:pPr>
-              <a:defRPr sz="850">
-                <a:solidFill>
-                  <a:srgbClr val="595959"/>
-                </a:solidFill>
-                <a:latin typeface="Calibri"/>
-              </a:defRPr>
-            </a:pPr>
-            <a:r>
-              <a:t>FAZ 39 | FEZ 42</a:t>
-            </a:r>
-          </a:p>
-          <a:p>
-            <a:pPr>
-              <a:defRPr sz="850" b="1">
-                <a:solidFill>
-                  <a:srgbClr val="C00000"/>
-                </a:solidFill>
-                <a:latin typeface="Calibri"/>
-              </a:defRPr>
-            </a:pPr>
-            <a:r>
-              <a:t>GP: 0 (Kritisch)</a:t>
-            </a:r>
-          </a:p>
-        </p:txBody>
-      </p:sp>
-      <p:sp>
-        <p:nvSpPr>
-          <p:cNvPr id="26" name="Rounded Rectangle 25"/>
-          <p:cNvSpPr/>
-          <p:nvPr/>
-        </p:nvSpPr>
-        <p:spPr>
-          <a:xfrm>
-            <a:off x="7973568" y="3566160"/>
-            <a:ext cx="1691640" cy="1280160"/>
-          </a:xfrm>
-          <a:prstGeom prst="roundRect">
-            <a:avLst/>
-          </a:prstGeom>
-          <a:solidFill>
-            <a:srgbClr val="FEF2ED"/>
-          </a:solidFill>
-          <a:ln w="19050">
-            <a:solidFill>
-              <a:srgbClr val="C00000"/>
-            </a:solidFill>
-          </a:ln>
-        </p:spPr>
-        <p:style>
-          <a:lnRef idx="1">
-            <a:schemeClr val="accent1"/>
-          </a:lnRef>
-          <a:fillRef idx="3">
-            <a:schemeClr val="accent1"/>
-          </a:fillRef>
-          <a:effectRef idx="2">
-            <a:schemeClr val="accent1"/>
-          </a:effectRef>
-          <a:fontRef idx="minor">
-            <a:schemeClr val="lt1"/>
-          </a:fontRef>
-        </p:style>
-        <p:txBody>
-          <a:bodyPr rtlCol="0" anchor="ctr"/>
-          <a:lstStyle/>
-          <a:p>
-            <a:pPr algn="ctr"/>
-          </a:p>
-        </p:txBody>
-      </p:sp>
-      <p:sp>
-        <p:nvSpPr>
-          <p:cNvPr id="27" name="TextBox 26"/>
-          <p:cNvSpPr txBox="1"/>
-          <p:nvPr/>
-        </p:nvSpPr>
-        <p:spPr>
-          <a:xfrm>
-            <a:off x="8046720" y="3639312"/>
-            <a:ext cx="1545336" cy="1133856"/>
-          </a:xfrm>
-          <a:prstGeom prst="rect">
-            <a:avLst/>
-          </a:prstGeom>
-          <a:noFill/>
-        </p:spPr>
-        <p:txBody>
-          <a:bodyPr wrap="square">
-            <a:spAutoFit/>
-          </a:bodyPr>
-          <a:lstStyle/>
-          <a:p>
-            <a:pPr>
-              <a:defRPr sz="1050" b="1">
-                <a:solidFill>
-                  <a:srgbClr val="9C0006"/>
-                </a:solidFill>
-                <a:latin typeface="Calibri"/>
-              </a:defRPr>
-            </a:pPr>
-            <a:r>
-              <a:t>V12: Abnahme</a:t>
-            </a:r>
-          </a:p>
-          <a:p>
-            <a:pPr>
-              <a:defRPr sz="950" b="1">
-                <a:solidFill>
-                  <a:srgbClr val="262626"/>
-                </a:solidFill>
-                <a:latin typeface="Calibri"/>
-              </a:defRPr>
-            </a:pPr>
-            <a:r>
-              <a:t>Dauer: 2 Tage</a:t>
-            </a:r>
-          </a:p>
-          <a:p>
-            <a:pPr>
-              <a:defRPr sz="850">
-                <a:solidFill>
-                  <a:srgbClr val="595959"/>
-                </a:solidFill>
-                <a:latin typeface="Calibri"/>
-              </a:defRPr>
-            </a:pPr>
-            <a:r>
-              <a:t>FAZ 42 | FEZ 44</a:t>
-            </a:r>
-          </a:p>
-          <a:p>
-            <a:pPr>
-              <a:defRPr sz="850" b="1">
-                <a:solidFill>
-                  <a:srgbClr val="C00000"/>
-                </a:solidFill>
-                <a:latin typeface="Calibri"/>
-              </a:defRPr>
-            </a:pPr>
-            <a:r>
-              <a:t>GP: 0 (Kritisch)</a:t>
-            </a:r>
-          </a:p>
-        </p:txBody>
-      </p:sp>
-      <p:sp>
-        <p:nvSpPr>
-          <p:cNvPr id="28" name="Rounded Rectangle 27"/>
-          <p:cNvSpPr/>
-          <p:nvPr/>
-        </p:nvSpPr>
-        <p:spPr>
-          <a:xfrm>
-            <a:off x="9784080" y="3566160"/>
-            <a:ext cx="1691640" cy="1280160"/>
-          </a:xfrm>
-          <a:prstGeom prst="roundRect">
-            <a:avLst/>
-          </a:prstGeom>
-          <a:solidFill>
-            <a:srgbClr val="FEF2ED"/>
-          </a:solidFill>
-          <a:ln w="19050">
-            <a:solidFill>
-              <a:srgbClr val="C00000"/>
-            </a:solidFill>
-          </a:ln>
-        </p:spPr>
-        <p:style>
-          <a:lnRef idx="1">
-            <a:schemeClr val="accent1"/>
-          </a:lnRef>
-          <a:fillRef idx="3">
-            <a:schemeClr val="accent1"/>
-          </a:fillRef>
-          <a:effectRef idx="2">
-            <a:schemeClr val="accent1"/>
-          </a:effectRef>
-          <a:fontRef idx="minor">
-            <a:schemeClr val="lt1"/>
-          </a:fontRef>
-        </p:style>
-        <p:txBody>
-          <a:bodyPr rtlCol="0" anchor="ctr"/>
-          <a:lstStyle/>
-          <a:p>
-            <a:pPr algn="ctr"/>
-          </a:p>
-        </p:txBody>
-      </p:sp>
-      <p:sp>
-        <p:nvSpPr>
-          <p:cNvPr id="29" name="TextBox 28"/>
-          <p:cNvSpPr txBox="1"/>
-          <p:nvPr/>
-        </p:nvSpPr>
-        <p:spPr>
-          <a:xfrm>
-            <a:off x="9857232" y="3639312"/>
-            <a:ext cx="1545336" cy="1133856"/>
-          </a:xfrm>
-          <a:prstGeom prst="rect">
-            <a:avLst/>
-          </a:prstGeom>
-          <a:noFill/>
-        </p:spPr>
-        <p:txBody>
-          <a:bodyPr wrap="square">
-            <a:spAutoFit/>
-          </a:bodyPr>
-          <a:lstStyle/>
-          <a:p>
-            <a:pPr>
-              <a:defRPr sz="1050" b="1">
-                <a:solidFill>
-                  <a:srgbClr val="9C0006"/>
-                </a:solidFill>
-                <a:latin typeface="Calibri"/>
-              </a:defRPr>
-            </a:pPr>
-            <a:r>
-              <a:t>V13/14: Abschluss</a:t>
-            </a:r>
-          </a:p>
-          <a:p>
-            <a:pPr>
-              <a:defRPr sz="950" b="1">
-                <a:solidFill>
-                  <a:srgbClr val="262626"/>
-                </a:solidFill>
-                <a:latin typeface="Calibri"/>
-              </a:defRPr>
-            </a:pPr>
-            <a:r>
-              <a:t>Dauer: 2 Tage</a:t>
-            </a:r>
-          </a:p>
-          <a:p>
-            <a:pPr>
-              <a:defRPr sz="850">
-                <a:solidFill>
-                  <a:srgbClr val="595959"/>
-                </a:solidFill>
-                <a:latin typeface="Calibri"/>
-              </a:defRPr>
-            </a:pPr>
-            <a:r>
-              <a:t>FAZ 44 | FEZ 46</a:t>
-            </a:r>
-          </a:p>
-          <a:p>
-            <a:pPr>
-              <a:defRPr sz="850" b="1">
-                <a:solidFill>
-                  <a:srgbClr val="C00000"/>
-                </a:solidFill>
-                <a:latin typeface="Calibri"/>
-              </a:defRPr>
-            </a:pPr>
-            <a:r>
-              <a:t>GP: 0 (Kritisch)</a:t>
-            </a:r>
-          </a:p>
-        </p:txBody>
-      </p:sp>
-      <p:sp>
-        <p:nvSpPr>
-          <p:cNvPr id="30" name="Rounded Rectangle 29"/>
-          <p:cNvSpPr/>
-          <p:nvPr/>
-        </p:nvSpPr>
-        <p:spPr>
-          <a:xfrm>
-            <a:off x="731520" y="5394960"/>
-            <a:ext cx="10698480" cy="868680"/>
-          </a:xfrm>
-          <a:prstGeom prst="roundRect">
-            <a:avLst/>
-          </a:prstGeom>
-          <a:solidFill>
-            <a:srgbClr val="DEEBF7"/>
-          </a:solidFill>
-          <a:ln w="12700">
-            <a:solidFill>
-              <a:srgbClr val="2F5597"/>
-            </a:solidFill>
-          </a:ln>
-        </p:spPr>
-        <p:style>
-          <a:lnRef idx="1">
-            <a:schemeClr val="accent1"/>
-          </a:lnRef>
-          <a:fillRef idx="3">
-            <a:schemeClr val="accent1"/>
-          </a:fillRef>
-          <a:effectRef idx="2">
-            <a:schemeClr val="accent1"/>
-          </a:effectRef>
-          <a:fontRef idx="minor">
-            <a:schemeClr val="lt1"/>
-          </a:fontRef>
-        </p:style>
-        <p:txBody>
-          <a:bodyPr rtlCol="0" anchor="ctr"/>
-          <a:lstStyle/>
-          <a:p>
-            <a:pPr algn="ctr"/>
-          </a:p>
-        </p:txBody>
-      </p:sp>
-      <p:sp>
-        <p:nvSpPr>
-          <p:cNvPr id="31" name="TextBox 30"/>
-          <p:cNvSpPr txBox="1"/>
-          <p:nvPr/>
-        </p:nvSpPr>
-        <p:spPr>
-          <a:xfrm>
-            <a:off x="914400" y="5440680"/>
-            <a:ext cx="10332720" cy="777240"/>
-          </a:xfrm>
-          <a:prstGeom prst="rect">
-            <a:avLst/>
-          </a:prstGeom>
-          <a:noFill/>
-        </p:spPr>
-        <p:txBody>
-          <a:bodyPr wrap="square">
-            <a:spAutoFit/>
-          </a:bodyPr>
-          <a:lstStyle/>
-          <a:p>
-            <a:pPr>
-              <a:defRPr sz="1000" b="1">
-                <a:solidFill>
-                  <a:srgbClr val="1F497D"/>
-                </a:solidFill>
-                <a:latin typeface="Calibri"/>
-              </a:defRPr>
-            </a:pPr>
-            <a:r>
-              <a:t>Puffer-Analyse: V10 'Entsorgung Altdrucker (ElektroG)' | Dauer: 2 Tage | FAZ: Tag 39 / FEZ: Tag 41 | SAZ: Tag 40 / SEZ: Tag 42</a:t>
-            </a:r>
-          </a:p>
-          <a:p>
-            <a:pPr>
-              <a:defRPr sz="950">
-                <a:solidFill>
-                  <a:srgbClr val="262626"/>
-                </a:solidFill>
-                <a:latin typeface="Calibri"/>
-              </a:defRPr>
-            </a:pPr>
-            <a:r>
-              <a:t>➔ V10 besitzt 1 Tag Gesamtpuffer (GP = 1). Da die Montage vor Ort (V11) 3 Tage beansprucht und parallel läuft, verzögert eine eintägige Verzögerung bei der Altdrucker-Abholung den Gesamtabgabetermin (Tag 46) nicht.</a:t>
+              <a:t>KRITISCHER PFAD (ROT): V1 ➔ V2 ➔ V3 ➔ V4 ➔ V5 ➔ V6 ➔ V7 ➔ V8 ➔ V9 ➔ V11 ➔ V12 ➔ V13 ➔ V14  |  DAUER: 46 TAGE  |  PUFFER V10: 1 TAG</a:t>
             </a:r>
           </a:p>
         </p:txBody>
@@ -18246,4 +18432,324 @@
   </a:objectDefaults>
   <a:extraClrSchemeLst/>
 </a:theme>
+</file>
+
+<file path=ppt/theme/theme2.xml><?xml version="1.0" encoding="utf-8"?>
+<a:theme xmlns:a="http://schemas.openxmlformats.org/drawingml/2006/main" name="Office Theme">
+  <a:themeElements>
+    <a:clrScheme name="Office">
+      <a:dk1>
+        <a:sysClr val="windowText" lastClr="000000"/>
+      </a:dk1>
+      <a:lt1>
+        <a:sysClr val="window" lastClr="FFFFFF"/>
+      </a:lt1>
+      <a:dk2>
+        <a:srgbClr val="1F497D"/>
+      </a:dk2>
+      <a:lt2>
+        <a:srgbClr val="EEECE1"/>
+      </a:lt2>
+      <a:accent1>
+        <a:srgbClr val="4F81BD"/>
+      </a:accent1>
+      <a:accent2>
+        <a:srgbClr val="C0504D"/>
+      </a:accent2>
+      <a:accent3>
+        <a:srgbClr val="9BBB59"/>
+      </a:accent3>
+      <a:accent4>
+        <a:srgbClr val="8064A2"/>
+      </a:accent4>
+      <a:accent5>
+        <a:srgbClr val="4BACC6"/>
+      </a:accent5>
+      <a:accent6>
+        <a:srgbClr val="F79646"/>
+      </a:accent6>
+      <a:hlink>
+        <a:srgbClr val="0000FF"/>
+      </a:hlink>
+      <a:folHlink>
+        <a:srgbClr val="800080"/>
+      </a:folHlink>
+    </a:clrScheme>
+    <a:fontScheme name="Office">
+      <a:majorFont>
+        <a:latin typeface="Calibri"/>
+        <a:ea typeface=""/>
+        <a:cs typeface=""/>
+        <a:font script="Jpan" typeface="ＭＳ Ｐゴシック"/>
+        <a:font script="Hang" typeface="맑은 고딕"/>
+        <a:font script="Hans" typeface="宋体"/>
+        <a:font script="Hant" typeface="新細明體"/>
+        <a:font script="Arab" typeface="Times New Roman"/>
+        <a:font script="Hebr" typeface="Times New Roman"/>
+        <a:font script="Thai" typeface="Angsana New"/>
+        <a:font script="Ethi" typeface="Nyala"/>
+        <a:font script="Beng" typeface="Vrinda"/>
+        <a:font script="Gujr" typeface="Shruti"/>
+        <a:font script="Khmr" typeface="MoolBoran"/>
+        <a:font script="Knda" typeface="Tunga"/>
+        <a:font script="Guru" typeface="Raavi"/>
+        <a:font script="Cans" typeface="Euphemia"/>
+        <a:font script="Cher" typeface="Plantagenet Cherokee"/>
+        <a:font script="Yiii" typeface="Microsoft Yi Baiti"/>
+        <a:font script="Tibt" typeface="Microsoft Himalaya"/>
+        <a:font script="Thaa" typeface="MV Boli"/>
+        <a:font script="Deva" typeface="Mangal"/>
+        <a:font script="Telu" typeface="Gautami"/>
+        <a:font script="Taml" typeface="Latha"/>
+        <a:font script="Syrc" typeface="Estrangelo Edessa"/>
+        <a:font script="Orya" typeface="Kalinga"/>
+        <a:font script="Mlym" typeface="Kartika"/>
+        <a:font script="Laoo" typeface="DokChampa"/>
+        <a:font script="Sinh" typeface="Iskoola Pota"/>
+        <a:font script="Mong" typeface="Mongolian Baiti"/>
+        <a:font script="Viet" typeface="Times New Roman"/>
+        <a:font script="Uigh" typeface="Microsoft Uighur"/>
+        <a:font script="Geor" typeface="Sylfaen"/>
+      </a:majorFont>
+      <a:minorFont>
+        <a:latin typeface="Calibri"/>
+        <a:ea typeface=""/>
+        <a:cs typeface=""/>
+        <a:font script="Jpan" typeface="ＭＳ Ｐゴシック"/>
+        <a:font script="Hang" typeface="맑은 고딕"/>
+        <a:font script="Hans" typeface="宋体"/>
+        <a:font script="Hant" typeface="新細明體"/>
+        <a:font script="Arab" typeface="Arial"/>
+        <a:font script="Hebr" typeface="Arial"/>
+        <a:font script="Thai" typeface="Cordia New"/>
+        <a:font script="Ethi" typeface="Nyala"/>
+        <a:font script="Beng" typeface="Vrinda"/>
+        <a:font script="Gujr" typeface="Shruti"/>
+        <a:font script="Khmr" typeface="DaunPenh"/>
+        <a:font script="Knda" typeface="Tunga"/>
+        <a:font script="Guru" typeface="Raavi"/>
+        <a:font script="Cans" typeface="Euphemia"/>
+        <a:font script="Cher" typeface="Plantagenet Cherokee"/>
+        <a:font script="Yiii" typeface="Microsoft Yi Baiti"/>
+        <a:font script="Tibt" typeface="Microsoft Himalaya"/>
+        <a:font script="Thaa" typeface="MV Boli"/>
+        <a:font script="Deva" typeface="Mangal"/>
+        <a:font script="Telu" typeface="Gautami"/>
+        <a:font script="Taml" typeface="Latha"/>
+        <a:font script="Syrc" typeface="Estrangelo Edessa"/>
+        <a:font script="Orya" typeface="Kalinga"/>
+        <a:font script="Mlym" typeface="Kartika"/>
+        <a:font script="Laoo" typeface="DokChampa"/>
+        <a:font script="Sinh" typeface="Iskoola Pota"/>
+        <a:font script="Mong" typeface="Mongolian Baiti"/>
+        <a:font script="Viet" typeface="Arial"/>
+        <a:font script="Uigh" typeface="Microsoft Uighur"/>
+        <a:font script="Geor" typeface="Sylfaen"/>
+      </a:minorFont>
+    </a:fontScheme>
+    <a:fmtScheme name="Office">
+      <a:fillStyleLst>
+        <a:solidFill>
+          <a:schemeClr val="phClr"/>
+        </a:solidFill>
+        <a:gradFill rotWithShape="1">
+          <a:gsLst>
+            <a:gs pos="0">
+              <a:schemeClr val="phClr">
+                <a:tint val="50000"/>
+                <a:satMod val="300000"/>
+              </a:schemeClr>
+            </a:gs>
+            <a:gs pos="35000">
+              <a:schemeClr val="phClr">
+                <a:tint val="37000"/>
+                <a:satMod val="300000"/>
+              </a:schemeClr>
+            </a:gs>
+            <a:gs pos="100000">
+              <a:schemeClr val="phClr">
+                <a:tint val="15000"/>
+                <a:satMod val="350000"/>
+              </a:schemeClr>
+            </a:gs>
+          </a:gsLst>
+          <a:lin ang="16200000" scaled="1"/>
+        </a:gradFill>
+        <a:gradFill rotWithShape="1">
+          <a:gsLst>
+            <a:gs pos="0">
+              <a:schemeClr val="phClr">
+                <a:tint val="100000"/>
+                <a:shade val="100000"/>
+                <a:satMod val="130000"/>
+              </a:schemeClr>
+            </a:gs>
+            <a:gs pos="100000">
+              <a:schemeClr val="phClr">
+                <a:tint val="50000"/>
+                <a:shade val="100000"/>
+                <a:satMod val="350000"/>
+              </a:schemeClr>
+            </a:gs>
+          </a:gsLst>
+          <a:lin ang="16200000" scaled="0"/>
+        </a:gradFill>
+      </a:fillStyleLst>
+      <a:lnStyleLst>
+        <a:ln w="9525" cap="flat" cmpd="sng" algn="ctr">
+          <a:solidFill>
+            <a:schemeClr val="phClr">
+              <a:shade val="95000"/>
+              <a:satMod val="105000"/>
+            </a:schemeClr>
+          </a:solidFill>
+          <a:prstDash val="solid"/>
+        </a:ln>
+        <a:ln w="25400" cap="flat" cmpd="sng" algn="ctr">
+          <a:solidFill>
+            <a:schemeClr val="phClr"/>
+          </a:solidFill>
+          <a:prstDash val="solid"/>
+        </a:ln>
+        <a:ln w="38100" cap="flat" cmpd="sng" algn="ctr">
+          <a:solidFill>
+            <a:schemeClr val="phClr"/>
+          </a:solidFill>
+          <a:prstDash val="solid"/>
+        </a:ln>
+      </a:lnStyleLst>
+      <a:effectStyleLst>
+        <a:effectStyle>
+          <a:effectLst>
+            <a:outerShdw blurRad="40000" dist="20000" dir="5400000" rotWithShape="0">
+              <a:srgbClr val="000000">
+                <a:alpha val="38000"/>
+              </a:srgbClr>
+            </a:outerShdw>
+          </a:effectLst>
+        </a:effectStyle>
+        <a:effectStyle>
+          <a:effectLst>
+            <a:outerShdw blurRad="40000" dist="23000" dir="5400000" rotWithShape="0">
+              <a:srgbClr val="000000">
+                <a:alpha val="35000"/>
+              </a:srgbClr>
+            </a:outerShdw>
+          </a:effectLst>
+        </a:effectStyle>
+        <a:effectStyle>
+          <a:effectLst>
+            <a:outerShdw blurRad="40000" dist="23000" dir="5400000" rotWithShape="0">
+              <a:srgbClr val="000000">
+                <a:alpha val="35000"/>
+              </a:srgbClr>
+            </a:outerShdw>
+          </a:effectLst>
+          <a:scene3d>
+            <a:camera prst="orthographicFront">
+              <a:rot lat="0" lon="0" rev="0"/>
+            </a:camera>
+            <a:lightRig rig="threePt" dir="t">
+              <a:rot lat="0" lon="0" rev="1200000"/>
+            </a:lightRig>
+          </a:scene3d>
+          <a:sp3d>
+            <a:bevelT w="63500" h="25400"/>
+          </a:sp3d>
+        </a:effectStyle>
+      </a:effectStyleLst>
+      <a:bgFillStyleLst>
+        <a:solidFill>
+          <a:schemeClr val="phClr"/>
+        </a:solidFill>
+        <a:gradFill rotWithShape="1">
+          <a:gsLst>
+            <a:gs pos="0">
+              <a:schemeClr val="phClr">
+                <a:tint val="40000"/>
+                <a:satMod val="350000"/>
+              </a:schemeClr>
+            </a:gs>
+            <a:gs pos="40000">
+              <a:schemeClr val="phClr">
+                <a:tint val="45000"/>
+                <a:shade val="99000"/>
+                <a:satMod val="350000"/>
+              </a:schemeClr>
+            </a:gs>
+            <a:gs pos="100000">
+              <a:schemeClr val="phClr">
+                <a:shade val="20000"/>
+                <a:satMod val="255000"/>
+              </a:schemeClr>
+            </a:gs>
+          </a:gsLst>
+          <a:path path="circle">
+            <a:fillToRect l="50000" t="-80000" r="50000" b="180000"/>
+          </a:path>
+        </a:gradFill>
+        <a:gradFill rotWithShape="1">
+          <a:gsLst>
+            <a:gs pos="0">
+              <a:schemeClr val="phClr">
+                <a:tint val="80000"/>
+                <a:satMod val="300000"/>
+              </a:schemeClr>
+            </a:gs>
+            <a:gs pos="100000">
+              <a:schemeClr val="phClr">
+                <a:shade val="30000"/>
+                <a:satMod val="200000"/>
+              </a:schemeClr>
+            </a:gs>
+          </a:gsLst>
+          <a:path path="circle">
+            <a:fillToRect l="50000" t="50000" r="50000" b="50000"/>
+          </a:path>
+        </a:gradFill>
+      </a:bgFillStyleLst>
+    </a:fmtScheme>
+  </a:themeElements>
+  <a:objectDefaults>
+    <a:spDef>
+      <a:spPr/>
+      <a:bodyPr/>
+      <a:lstStyle/>
+      <a:style>
+        <a:lnRef idx="1">
+          <a:schemeClr val="accent1"/>
+        </a:lnRef>
+        <a:fillRef idx="3">
+          <a:schemeClr val="accent1"/>
+        </a:fillRef>
+        <a:effectRef idx="2">
+          <a:schemeClr val="accent1"/>
+        </a:effectRef>
+        <a:fontRef idx="minor">
+          <a:schemeClr val="lt1"/>
+        </a:fontRef>
+      </a:style>
+    </a:spDef>
+    <a:lnDef>
+      <a:spPr/>
+      <a:bodyPr/>
+      <a:lstStyle/>
+      <a:style>
+        <a:lnRef idx="2">
+          <a:schemeClr val="accent1"/>
+        </a:lnRef>
+        <a:fillRef idx="0">
+          <a:schemeClr val="accent1"/>
+        </a:fillRef>
+        <a:effectRef idx="1">
+          <a:schemeClr val="accent1"/>
+        </a:effectRef>
+        <a:fontRef idx="minor">
+          <a:schemeClr val="tx1"/>
+        </a:fontRef>
+      </a:style>
+    </a:lnDef>
+  </a:objectDefaults>
+  <a:extraClrSchemeLst/>
+</a:theme>
 </file>
</xml_diff>